<commit_message>
Fix slide 7 feedback-loop diagram: straight edge-to-edge connectors
</commit_message>
<xml_diff>
--- a/E-Waste-Right-to-Repair.pptx
+++ b/E-Waste-Right-to-Repair.pptx
@@ -4282,7 +4282,7 @@
             <a:off x="6035040" y="182880"/>
             <a:ext cx="5669280" cy="6400800"/>
           </a:xfrm>
-          <a:prstGeom prst="bentConnector3">
+          <a:prstGeom prst="line">
             <a:avLst/>
           </a:prstGeom>
           <a:ln w="31750">
@@ -5605,361 +5605,27 @@
           </a:p>
         </p:txBody>
       </p:sp>
-      <p:sp>
-        <p:nvSpPr>
-          <p:cNvPr id="5" name="Rounded Rectangle 4"/>
-          <p:cNvSpPr/>
-          <p:nvPr/>
-        </p:nvSpPr>
-        <p:spPr>
-          <a:xfrm>
-            <a:off x="4946904" y="1143000"/>
-            <a:ext cx="2286000" cy="914400"/>
-          </a:xfrm>
-          <a:prstGeom prst="roundRect">
-            <a:avLst/>
-          </a:prstGeom>
-          <a:solidFill>
-            <a:srgbClr val="1C1C1E"/>
-          </a:solidFill>
-          <a:ln w="25400">
-            <a:solidFill>
-              <a:srgbClr val="3DBFB8"/>
-            </a:solidFill>
-          </a:ln>
-          <a:effectLst/>
-        </p:spPr>
-        <p:style>
-          <a:lnRef idx="1">
-            <a:schemeClr val="accent1"/>
-          </a:lnRef>
-          <a:fillRef idx="3">
-            <a:schemeClr val="accent1"/>
-          </a:fillRef>
-          <a:effectRef idx="2">
-            <a:schemeClr val="accent1"/>
-          </a:effectRef>
-          <a:fontRef idx="minor">
-            <a:schemeClr val="lt1"/>
-          </a:fontRef>
-        </p:style>
-        <p:txBody>
-          <a:bodyPr rtlCol="0" anchor="ctr" wrap="square"/>
-          <a:lstStyle/>
-          <a:p>
-            <a:pPr algn="ctr"/>
-            <a:r>
-              <a:rPr sz="1050" b="1" i="0">
-                <a:solidFill>
-                  <a:srgbClr val="3DBFB8"/>
-                </a:solidFill>
-                <a:latin typeface="IBM Plex Mono"/>
-              </a:rPr>
-              <a:t>LOCAL REPAIR</a:t>
-            </a:r>
-          </a:p>
-          <a:p>
-            <a:pPr algn="ctr"/>
-            <a:r>
-              <a:rPr sz="1050" b="1" i="0">
-                <a:solidFill>
-                  <a:srgbClr val="3DBFB8"/>
-                </a:solidFill>
-                <a:latin typeface="IBM Plex Mono"/>
-              </a:rPr>
-              <a:t>CULTURE GROWS</a:t>
-            </a:r>
-          </a:p>
-        </p:txBody>
-      </p:sp>
-      <p:sp>
-        <p:nvSpPr>
-          <p:cNvPr id="6" name="Rounded Rectangle 5"/>
-          <p:cNvSpPr/>
-          <p:nvPr/>
-        </p:nvSpPr>
-        <p:spPr>
-          <a:xfrm>
-            <a:off x="7077536" y="2690995"/>
-            <a:ext cx="2286000" cy="914400"/>
-          </a:xfrm>
-          <a:prstGeom prst="roundRect">
-            <a:avLst/>
-          </a:prstGeom>
-          <a:solidFill>
-            <a:srgbClr val="1C1C1E"/>
-          </a:solidFill>
-          <a:ln w="25400">
-            <a:solidFill>
-              <a:srgbClr val="F5A321"/>
-            </a:solidFill>
-          </a:ln>
-          <a:effectLst/>
-        </p:spPr>
-        <p:style>
-          <a:lnRef idx="1">
-            <a:schemeClr val="accent1"/>
-          </a:lnRef>
-          <a:fillRef idx="3">
-            <a:schemeClr val="accent1"/>
-          </a:fillRef>
-          <a:effectRef idx="2">
-            <a:schemeClr val="accent1"/>
-          </a:effectRef>
-          <a:fontRef idx="minor">
-            <a:schemeClr val="lt1"/>
-          </a:fontRef>
-        </p:style>
-        <p:txBody>
-          <a:bodyPr rtlCol="0" anchor="ctr" wrap="square"/>
-          <a:lstStyle/>
-          <a:p>
-            <a:pPr algn="ctr"/>
-            <a:r>
-              <a:rPr sz="1050" b="1" i="0">
-                <a:solidFill>
-                  <a:srgbClr val="F5A321"/>
-                </a:solidFill>
-                <a:latin typeface="IBM Plex Mono"/>
-              </a:rPr>
-              <a:t>DEMAND FOR NEW</a:t>
-            </a:r>
-          </a:p>
-          <a:p>
-            <a:pPr algn="ctr"/>
-            <a:r>
-              <a:rPr sz="1050" b="1" i="0">
-                <a:solidFill>
-                  <a:srgbClr val="F5A321"/>
-                </a:solidFill>
-                <a:latin typeface="IBM Plex Mono"/>
-              </a:rPr>
-              <a:t>DEVICES DROPS</a:t>
-            </a:r>
-          </a:p>
-        </p:txBody>
-      </p:sp>
-      <p:sp>
-        <p:nvSpPr>
-          <p:cNvPr id="7" name="Rounded Rectangle 6"/>
-          <p:cNvSpPr/>
-          <p:nvPr/>
-        </p:nvSpPr>
-        <p:spPr>
-          <a:xfrm>
-            <a:off x="6263707" y="5195704"/>
-            <a:ext cx="2286000" cy="914400"/>
-          </a:xfrm>
-          <a:prstGeom prst="roundRect">
-            <a:avLst/>
-          </a:prstGeom>
-          <a:solidFill>
-            <a:srgbClr val="1C1C1E"/>
-          </a:solidFill>
-          <a:ln w="25400">
-            <a:solidFill>
-              <a:srgbClr val="F5A321"/>
-            </a:solidFill>
-          </a:ln>
-          <a:effectLst/>
-        </p:spPr>
-        <p:style>
-          <a:lnRef idx="1">
-            <a:schemeClr val="accent1"/>
-          </a:lnRef>
-          <a:fillRef idx="3">
-            <a:schemeClr val="accent1"/>
-          </a:fillRef>
-          <a:effectRef idx="2">
-            <a:schemeClr val="accent1"/>
-          </a:effectRef>
-          <a:fontRef idx="minor">
-            <a:schemeClr val="lt1"/>
-          </a:fontRef>
-        </p:style>
-        <p:txBody>
-          <a:bodyPr rtlCol="0" anchor="ctr" wrap="square"/>
-          <a:lstStyle/>
-          <a:p>
-            <a:pPr algn="ctr"/>
-            <a:r>
-              <a:rPr sz="1050" b="1" i="0">
-                <a:solidFill>
-                  <a:srgbClr val="F5A321"/>
-                </a:solidFill>
-                <a:latin typeface="IBM Plex Mono"/>
-              </a:rPr>
-              <a:t>MANUFACTURERS FACE</a:t>
-            </a:r>
-          </a:p>
-          <a:p>
-            <a:pPr algn="ctr"/>
-            <a:r>
-              <a:rPr sz="1050" b="1" i="0">
-                <a:solidFill>
-                  <a:srgbClr val="F5A321"/>
-                </a:solidFill>
-                <a:latin typeface="IBM Plex Mono"/>
-              </a:rPr>
-              <a:t>MARKET PRESSURE</a:t>
-            </a:r>
-          </a:p>
-        </p:txBody>
-      </p:sp>
-      <p:sp>
-        <p:nvSpPr>
-          <p:cNvPr id="8" name="Rounded Rectangle 7"/>
-          <p:cNvSpPr/>
-          <p:nvPr/>
-        </p:nvSpPr>
-        <p:spPr>
-          <a:xfrm>
-            <a:off x="3630100" y="5195704"/>
-            <a:ext cx="2286000" cy="914400"/>
-          </a:xfrm>
-          <a:prstGeom prst="roundRect">
-            <a:avLst/>
-          </a:prstGeom>
-          <a:solidFill>
-            <a:srgbClr val="1C1C1E"/>
-          </a:solidFill>
-          <a:ln w="25400">
-            <a:solidFill>
-              <a:srgbClr val="3DBFB8"/>
-            </a:solidFill>
-          </a:ln>
-          <a:effectLst/>
-        </p:spPr>
-        <p:style>
-          <a:lnRef idx="1">
-            <a:schemeClr val="accent1"/>
-          </a:lnRef>
-          <a:fillRef idx="3">
-            <a:schemeClr val="accent1"/>
-          </a:fillRef>
-          <a:effectRef idx="2">
-            <a:schemeClr val="accent1"/>
-          </a:effectRef>
-          <a:fontRef idx="minor">
-            <a:schemeClr val="lt1"/>
-          </a:fontRef>
-        </p:style>
-        <p:txBody>
-          <a:bodyPr rtlCol="0" anchor="ctr" wrap="square"/>
-          <a:lstStyle/>
-          <a:p>
-            <a:pPr algn="ctr"/>
-            <a:r>
-              <a:rPr sz="1050" b="1" i="0">
-                <a:solidFill>
-                  <a:srgbClr val="3DBFB8"/>
-                </a:solidFill>
-                <a:latin typeface="IBM Plex Mono"/>
-              </a:rPr>
-              <a:t>PRODUCTION &amp;</a:t>
-            </a:r>
-          </a:p>
-          <a:p>
-            <a:pPr algn="ctr"/>
-            <a:r>
-              <a:rPr sz="1050" b="1" i="0">
-                <a:solidFill>
-                  <a:srgbClr val="3DBFB8"/>
-                </a:solidFill>
-                <a:latin typeface="IBM Plex Mono"/>
-              </a:rPr>
-              <a:t>MINING DECREASE</a:t>
-            </a:r>
-          </a:p>
-        </p:txBody>
-      </p:sp>
-      <p:sp>
-        <p:nvSpPr>
-          <p:cNvPr id="9" name="Rounded Rectangle 8"/>
-          <p:cNvSpPr/>
-          <p:nvPr/>
-        </p:nvSpPr>
-        <p:spPr>
-          <a:xfrm>
-            <a:off x="2816271" y="2690995"/>
-            <a:ext cx="2286000" cy="914400"/>
-          </a:xfrm>
-          <a:prstGeom prst="roundRect">
-            <a:avLst/>
-          </a:prstGeom>
-          <a:solidFill>
-            <a:srgbClr val="1C1C1E"/>
-          </a:solidFill>
-          <a:ln w="25400">
-            <a:solidFill>
-              <a:srgbClr val="3DBFB8"/>
-            </a:solidFill>
-          </a:ln>
-          <a:effectLst/>
-        </p:spPr>
-        <p:style>
-          <a:lnRef idx="1">
-            <a:schemeClr val="accent1"/>
-          </a:lnRef>
-          <a:fillRef idx="3">
-            <a:schemeClr val="accent1"/>
-          </a:fillRef>
-          <a:effectRef idx="2">
-            <a:schemeClr val="accent1"/>
-          </a:effectRef>
-          <a:fontRef idx="minor">
-            <a:schemeClr val="lt1"/>
-          </a:fontRef>
-        </p:style>
-        <p:txBody>
-          <a:bodyPr rtlCol="0" anchor="ctr" wrap="square"/>
-          <a:lstStyle/>
-          <a:p>
-            <a:pPr algn="ctr"/>
-            <a:r>
-              <a:rPr sz="1050" b="1" i="0">
-                <a:solidFill>
-                  <a:srgbClr val="3DBFB8"/>
-                </a:solidFill>
-                <a:latin typeface="IBM Plex Mono"/>
-              </a:rPr>
-              <a:t>GLOBAL E-WASTE</a:t>
-            </a:r>
-          </a:p>
-          <a:p>
-            <a:pPr algn="ctr"/>
-            <a:r>
-              <a:rPr sz="1050" b="1" i="0">
-                <a:solidFill>
-                  <a:srgbClr val="3DBFB8"/>
-                </a:solidFill>
-                <a:latin typeface="IBM Plex Mono"/>
-              </a:rPr>
-              <a:t>LOAD REDUCED</a:t>
-            </a:r>
-          </a:p>
-        </p:txBody>
-      </p:sp>
       <p:cxnSp>
         <p:nvCxnSpPr>
-          <p:cNvPr id="10" name="Connector 9"/>
+          <p:cNvPr id="5" name="Connector 4"/>
           <p:cNvCxnSpPr/>
           <p:nvPr/>
         </p:nvCxnSpPr>
         <p:spPr>
           <a:xfrm>
-            <a:off x="6089904" y="1600200"/>
-            <a:ext cx="2130632" cy="1547995"/>
-          </a:xfrm>
-          <a:prstGeom prst="bentConnector3">
+            <a:off x="6824626" y="2134007"/>
+            <a:ext cx="748153" cy="543564"/>
+          </a:xfrm>
+          <a:prstGeom prst="line">
             <a:avLst/>
           </a:prstGeom>
-          <a:ln w="22225">
+          <a:ln w="25400">
             <a:solidFill>
               <a:srgbClr val="F5A321"/>
             </a:solidFill>
             <a:tailEnd type="triangle" w="med" len="med"/>
           </a:ln>
+          <a:effectLst/>
         </p:spPr>
         <p:style>
           <a:lnRef idx="2">
@@ -5978,24 +5644,25 @@
       </p:cxnSp>
       <p:cxnSp>
         <p:nvCxnSpPr>
-          <p:cNvPr id="11" name="Connector 10"/>
+          <p:cNvPr id="6" name="Connector 5"/>
           <p:cNvCxnSpPr/>
           <p:nvPr/>
         </p:nvCxnSpPr>
         <p:spPr>
           <a:xfrm flipH="1">
-            <a:off x="7406707" y="3148195"/>
-            <a:ext cx="813829" cy="2504709"/>
-          </a:xfrm>
-          <a:prstGeom prst="bentConnector3">
+            <a:off x="7644692" y="3778403"/>
+            <a:ext cx="478572" cy="1472893"/>
+          </a:xfrm>
+          <a:prstGeom prst="line">
             <a:avLst/>
           </a:prstGeom>
-          <a:ln w="22225">
+          <a:ln w="25400">
             <a:solidFill>
               <a:srgbClr val="F5A321"/>
             </a:solidFill>
             <a:tailEnd type="triangle" w="med" len="med"/>
           </a:ln>
+          <a:effectLst/>
         </p:spPr>
         <p:style>
           <a:lnRef idx="2">
@@ -6014,24 +5681,25 @@
       </p:cxnSp>
       <p:cxnSp>
         <p:nvCxnSpPr>
-          <p:cNvPr id="12" name="Connector 11"/>
+          <p:cNvPr id="7" name="Connector 6"/>
           <p:cNvCxnSpPr/>
           <p:nvPr/>
         </p:nvCxnSpPr>
         <p:spPr>
           <a:xfrm flipH="1">
-            <a:off x="4773100" y="5652904"/>
-            <a:ext cx="2633607" cy="0"/>
-          </a:xfrm>
-          <a:prstGeom prst="bentConnector3">
+            <a:off x="6045233" y="5818321"/>
+            <a:ext cx="89341" cy="0"/>
+          </a:xfrm>
+          <a:prstGeom prst="line">
             <a:avLst/>
           </a:prstGeom>
-          <a:ln w="22225">
+          <a:ln w="25400">
             <a:solidFill>
               <a:srgbClr val="F5A321"/>
             </a:solidFill>
             <a:tailEnd type="triangle" w="med" len="med"/>
           </a:ln>
+          <a:effectLst/>
         </p:spPr>
         <p:style>
           <a:lnRef idx="2">
@@ -6050,24 +5718,25 @@
       </p:cxnSp>
       <p:cxnSp>
         <p:nvCxnSpPr>
-          <p:cNvPr id="13" name="Connector 12"/>
+          <p:cNvPr id="8" name="Connector 7"/>
           <p:cNvCxnSpPr/>
           <p:nvPr/>
         </p:nvCxnSpPr>
         <p:spPr>
           <a:xfrm flipH="1" flipV="1">
-            <a:off x="3959271" y="3148195"/>
-            <a:ext cx="813829" cy="2504709"/>
-          </a:xfrm>
-          <a:prstGeom prst="bentConnector3">
+            <a:off x="4056543" y="3778403"/>
+            <a:ext cx="478572" cy="1472893"/>
+          </a:xfrm>
+          <a:prstGeom prst="line">
             <a:avLst/>
           </a:prstGeom>
-          <a:ln w="22225">
+          <a:ln w="25400">
             <a:solidFill>
               <a:srgbClr val="F5A321"/>
             </a:solidFill>
             <a:tailEnd type="triangle" w="med" len="med"/>
           </a:ln>
+          <a:effectLst/>
         </p:spPr>
         <p:style>
           <a:lnRef idx="2">
@@ -6086,24 +5755,25 @@
       </p:cxnSp>
       <p:cxnSp>
         <p:nvCxnSpPr>
-          <p:cNvPr id="14" name="Connector 13"/>
+          <p:cNvPr id="9" name="Connector 8"/>
           <p:cNvCxnSpPr/>
           <p:nvPr/>
         </p:nvCxnSpPr>
         <p:spPr>
           <a:xfrm flipV="1">
-            <a:off x="3959271" y="1600200"/>
-            <a:ext cx="2130633" cy="1547995"/>
-          </a:xfrm>
-          <a:prstGeom prst="bentConnector3">
+            <a:off x="4607028" y="2134007"/>
+            <a:ext cx="748153" cy="543564"/>
+          </a:xfrm>
+          <a:prstGeom prst="line">
             <a:avLst/>
           </a:prstGeom>
-          <a:ln w="22225">
+          <a:ln w="25400">
             <a:solidFill>
               <a:srgbClr val="F5A321"/>
             </a:solidFill>
             <a:tailEnd type="triangle" w="med" len="med"/>
           </a:ln>
+          <a:effectLst/>
         </p:spPr>
         <p:style>
           <a:lnRef idx="2">
@@ -6122,14 +5792,349 @@
       </p:cxnSp>
       <p:sp>
         <p:nvSpPr>
+          <p:cNvPr id="10" name="Rounded Rectangle 9"/>
+          <p:cNvSpPr/>
+          <p:nvPr/>
+        </p:nvSpPr>
+        <p:spPr>
+          <a:xfrm>
+            <a:off x="4855464" y="1120140"/>
+            <a:ext cx="2468880" cy="960120"/>
+          </a:xfrm>
+          <a:prstGeom prst="roundRect">
+            <a:avLst/>
+          </a:prstGeom>
+          <a:solidFill>
+            <a:srgbClr val="1C1C1E"/>
+          </a:solidFill>
+          <a:ln w="28575">
+            <a:solidFill>
+              <a:srgbClr val="3DBFB8"/>
+            </a:solidFill>
+          </a:ln>
+          <a:effectLst/>
+        </p:spPr>
+        <p:style>
+          <a:lnRef idx="1">
+            <a:schemeClr val="accent1"/>
+          </a:lnRef>
+          <a:fillRef idx="3">
+            <a:schemeClr val="accent1"/>
+          </a:fillRef>
+          <a:effectRef idx="2">
+            <a:schemeClr val="accent1"/>
+          </a:effectRef>
+          <a:fontRef idx="minor">
+            <a:schemeClr val="lt1"/>
+          </a:fontRef>
+        </p:style>
+        <p:txBody>
+          <a:bodyPr rtlCol="0" anchor="ctr" wrap="square"/>
+          <a:lstStyle/>
+          <a:p>
+            <a:pPr algn="ctr"/>
+            <a:r>
+              <a:rPr sz="1050" b="1" i="0">
+                <a:solidFill>
+                  <a:srgbClr val="3DBFB8"/>
+                </a:solidFill>
+                <a:latin typeface="IBM Plex Mono"/>
+              </a:rPr>
+              <a:t>LOCAL REPAIR</a:t>
+            </a:r>
+          </a:p>
+          <a:p>
+            <a:pPr algn="ctr"/>
+            <a:r>
+              <a:rPr sz="1050" b="1" i="0">
+                <a:solidFill>
+                  <a:srgbClr val="3DBFB8"/>
+                </a:solidFill>
+                <a:latin typeface="IBM Plex Mono"/>
+              </a:rPr>
+              <a:t>CULTURE GROWS</a:t>
+            </a:r>
+          </a:p>
+        </p:txBody>
+      </p:sp>
+      <p:sp>
+        <p:nvSpPr>
+          <p:cNvPr id="11" name="Rounded Rectangle 10"/>
+          <p:cNvSpPr/>
+          <p:nvPr/>
+        </p:nvSpPr>
+        <p:spPr>
+          <a:xfrm>
+            <a:off x="7073061" y="2731318"/>
+            <a:ext cx="2468880" cy="960120"/>
+          </a:xfrm>
+          <a:prstGeom prst="roundRect">
+            <a:avLst/>
+          </a:prstGeom>
+          <a:solidFill>
+            <a:srgbClr val="1C1C1E"/>
+          </a:solidFill>
+          <a:ln w="28575">
+            <a:solidFill>
+              <a:srgbClr val="F5A321"/>
+            </a:solidFill>
+          </a:ln>
+          <a:effectLst/>
+        </p:spPr>
+        <p:style>
+          <a:lnRef idx="1">
+            <a:schemeClr val="accent1"/>
+          </a:lnRef>
+          <a:fillRef idx="3">
+            <a:schemeClr val="accent1"/>
+          </a:fillRef>
+          <a:effectRef idx="2">
+            <a:schemeClr val="accent1"/>
+          </a:effectRef>
+          <a:fontRef idx="minor">
+            <a:schemeClr val="lt1"/>
+          </a:fontRef>
+        </p:style>
+        <p:txBody>
+          <a:bodyPr rtlCol="0" anchor="ctr" wrap="square"/>
+          <a:lstStyle/>
+          <a:p>
+            <a:pPr algn="ctr"/>
+            <a:r>
+              <a:rPr sz="1050" b="1" i="0">
+                <a:solidFill>
+                  <a:srgbClr val="F5A321"/>
+                </a:solidFill>
+                <a:latin typeface="IBM Plex Mono"/>
+              </a:rPr>
+              <a:t>DEMAND FOR NEW</a:t>
+            </a:r>
+          </a:p>
+          <a:p>
+            <a:pPr algn="ctr"/>
+            <a:r>
+              <a:rPr sz="1050" b="1" i="0">
+                <a:solidFill>
+                  <a:srgbClr val="F5A321"/>
+                </a:solidFill>
+                <a:latin typeface="IBM Plex Mono"/>
+              </a:rPr>
+              <a:t>DEVICES DROPS</a:t>
+            </a:r>
+          </a:p>
+        </p:txBody>
+      </p:sp>
+      <p:sp>
+        <p:nvSpPr>
+          <p:cNvPr id="12" name="Rounded Rectangle 11"/>
+          <p:cNvSpPr/>
+          <p:nvPr/>
+        </p:nvSpPr>
+        <p:spPr>
+          <a:xfrm>
+            <a:off x="6226014" y="5338261"/>
+            <a:ext cx="2468880" cy="960120"/>
+          </a:xfrm>
+          <a:prstGeom prst="roundRect">
+            <a:avLst/>
+          </a:prstGeom>
+          <a:solidFill>
+            <a:srgbClr val="1C1C1E"/>
+          </a:solidFill>
+          <a:ln w="28575">
+            <a:solidFill>
+              <a:srgbClr val="F5A321"/>
+            </a:solidFill>
+          </a:ln>
+          <a:effectLst/>
+        </p:spPr>
+        <p:style>
+          <a:lnRef idx="1">
+            <a:schemeClr val="accent1"/>
+          </a:lnRef>
+          <a:fillRef idx="3">
+            <a:schemeClr val="accent1"/>
+          </a:fillRef>
+          <a:effectRef idx="2">
+            <a:schemeClr val="accent1"/>
+          </a:effectRef>
+          <a:fontRef idx="minor">
+            <a:schemeClr val="lt1"/>
+          </a:fontRef>
+        </p:style>
+        <p:txBody>
+          <a:bodyPr rtlCol="0" anchor="ctr" wrap="square"/>
+          <a:lstStyle/>
+          <a:p>
+            <a:pPr algn="ctr"/>
+            <a:r>
+              <a:rPr sz="1050" b="1" i="0">
+                <a:solidFill>
+                  <a:srgbClr val="F5A321"/>
+                </a:solidFill>
+                <a:latin typeface="IBM Plex Mono"/>
+              </a:rPr>
+              <a:t>MANUFACTURERS FACE</a:t>
+            </a:r>
+          </a:p>
+          <a:p>
+            <a:pPr algn="ctr"/>
+            <a:r>
+              <a:rPr sz="1050" b="1" i="0">
+                <a:solidFill>
+                  <a:srgbClr val="F5A321"/>
+                </a:solidFill>
+                <a:latin typeface="IBM Plex Mono"/>
+              </a:rPr>
+              <a:t>MARKET PRESSURE</a:t>
+            </a:r>
+          </a:p>
+        </p:txBody>
+      </p:sp>
+      <p:sp>
+        <p:nvSpPr>
+          <p:cNvPr id="13" name="Rounded Rectangle 12"/>
+          <p:cNvSpPr/>
+          <p:nvPr/>
+        </p:nvSpPr>
+        <p:spPr>
+          <a:xfrm>
+            <a:off x="3484913" y="5338261"/>
+            <a:ext cx="2468880" cy="960120"/>
+          </a:xfrm>
+          <a:prstGeom prst="roundRect">
+            <a:avLst/>
+          </a:prstGeom>
+          <a:solidFill>
+            <a:srgbClr val="1C1C1E"/>
+          </a:solidFill>
+          <a:ln w="28575">
+            <a:solidFill>
+              <a:srgbClr val="3DBFB8"/>
+            </a:solidFill>
+          </a:ln>
+          <a:effectLst/>
+        </p:spPr>
+        <p:style>
+          <a:lnRef idx="1">
+            <a:schemeClr val="accent1"/>
+          </a:lnRef>
+          <a:fillRef idx="3">
+            <a:schemeClr val="accent1"/>
+          </a:fillRef>
+          <a:effectRef idx="2">
+            <a:schemeClr val="accent1"/>
+          </a:effectRef>
+          <a:fontRef idx="minor">
+            <a:schemeClr val="lt1"/>
+          </a:fontRef>
+        </p:style>
+        <p:txBody>
+          <a:bodyPr rtlCol="0" anchor="ctr" wrap="square"/>
+          <a:lstStyle/>
+          <a:p>
+            <a:pPr algn="ctr"/>
+            <a:r>
+              <a:rPr sz="1050" b="1" i="0">
+                <a:solidFill>
+                  <a:srgbClr val="3DBFB8"/>
+                </a:solidFill>
+                <a:latin typeface="IBM Plex Mono"/>
+              </a:rPr>
+              <a:t>PRODUCTION &amp;</a:t>
+            </a:r>
+          </a:p>
+          <a:p>
+            <a:pPr algn="ctr"/>
+            <a:r>
+              <a:rPr sz="1050" b="1" i="0">
+                <a:solidFill>
+                  <a:srgbClr val="3DBFB8"/>
+                </a:solidFill>
+                <a:latin typeface="IBM Plex Mono"/>
+              </a:rPr>
+              <a:t>MINING DECREASE</a:t>
+            </a:r>
+          </a:p>
+        </p:txBody>
+      </p:sp>
+      <p:sp>
+        <p:nvSpPr>
+          <p:cNvPr id="14" name="Rounded Rectangle 13"/>
+          <p:cNvSpPr/>
+          <p:nvPr/>
+        </p:nvSpPr>
+        <p:spPr>
+          <a:xfrm>
+            <a:off x="2637866" y="2731318"/>
+            <a:ext cx="2468880" cy="960120"/>
+          </a:xfrm>
+          <a:prstGeom prst="roundRect">
+            <a:avLst/>
+          </a:prstGeom>
+          <a:solidFill>
+            <a:srgbClr val="1C1C1E"/>
+          </a:solidFill>
+          <a:ln w="28575">
+            <a:solidFill>
+              <a:srgbClr val="3DBFB8"/>
+            </a:solidFill>
+          </a:ln>
+          <a:effectLst/>
+        </p:spPr>
+        <p:style>
+          <a:lnRef idx="1">
+            <a:schemeClr val="accent1"/>
+          </a:lnRef>
+          <a:fillRef idx="3">
+            <a:schemeClr val="accent1"/>
+          </a:fillRef>
+          <a:effectRef idx="2">
+            <a:schemeClr val="accent1"/>
+          </a:effectRef>
+          <a:fontRef idx="minor">
+            <a:schemeClr val="lt1"/>
+          </a:fontRef>
+        </p:style>
+        <p:txBody>
+          <a:bodyPr rtlCol="0" anchor="ctr" wrap="square"/>
+          <a:lstStyle/>
+          <a:p>
+            <a:pPr algn="ctr"/>
+            <a:r>
+              <a:rPr sz="1050" b="1" i="0">
+                <a:solidFill>
+                  <a:srgbClr val="3DBFB8"/>
+                </a:solidFill>
+                <a:latin typeface="IBM Plex Mono"/>
+              </a:rPr>
+              <a:t>GLOBAL E-WASTE</a:t>
+            </a:r>
+          </a:p>
+          <a:p>
+            <a:pPr algn="ctr"/>
+            <a:r>
+              <a:rPr sz="1050" b="1" i="0">
+                <a:solidFill>
+                  <a:srgbClr val="3DBFB8"/>
+                </a:solidFill>
+                <a:latin typeface="IBM Plex Mono"/>
+              </a:rPr>
+              <a:t>LOAD REDUCED</a:t>
+            </a:r>
+          </a:p>
+        </p:txBody>
+      </p:sp>
+      <p:sp>
+        <p:nvSpPr>
           <p:cNvPr id="15" name="TextBox 14"/>
           <p:cNvSpPr txBox="1"/>
           <p:nvPr/>
         </p:nvSpPr>
         <p:spPr>
           <a:xfrm>
-            <a:off x="8595360" y="6309360"/>
-            <a:ext cx="3474720" cy="365760"/>
+            <a:off x="548640" y="6355080"/>
+            <a:ext cx="6400800" cy="365760"/>
           </a:xfrm>
           <a:prstGeom prst="rect">
             <a:avLst/>
@@ -6142,9 +6147,8 @@
           </a:bodyPr>
           <a:lstStyle/>
           <a:p>
-            <a:pPr algn="r"/>
-            <a:r>
-              <a:rPr sz="1100" b="0" i="0">
+            <a:r>
+              <a:rPr sz="1200" b="0" i="0">
                 <a:solidFill>
                   <a:srgbClr val="F0EDE6"/>
                 </a:solidFill>

</xml_diff>

<commit_message>
V2: More detail, personality, richer notes, remove attribution clutter
</commit_message>
<xml_diff>
--- a/E-Waste-Right-to-Repair.pptx
+++ b/E-Waste-Right-to-Repair.pptx
@@ -509,7 +509,19 @@
           <a:lstStyle/>
           <a:p>
             <a:r>
-              <a:t>Picture a specific place in your home — the junk drawer, the shoebox in the closet, the bin in the garage. It's full of cables you don't recognize, phones that won't turn on, gadgets whose purpose you've forgotten. Nearly every household in the developed world has one. That single, specific, embarrassing drawer is where this entire global crisis begins.</a:t>
+              <a:t>I want you to picture a specific place in your home. The junk drawer. The shoebox on the top shelf. The plastic bin in the garage you haven't opened in two years.</a:t>
+            </a:r>
+          </a:p>
+          <a:p/>
+          <a:p>
+            <a:r>
+              <a:t>It's full of cables you don't recognize anymore, phones that won't power on, chargers for devices you sold three years ago, earbuds with one dead side. The average American household has 3.4 unused electronic devices just sitting there — according to the EPA's 2021 consumer electronics data.</a:t>
+            </a:r>
+          </a:p>
+          <a:p/>
+          <a:p>
+            <a:r>
+              <a:t>That drawer is not harmless. It's not neutral. It is the opening scene of an environmental catastrophe that spans continents. And the fact that we all have one — that's exactly why this problem is both universal and invisible.</a:t>
             </a:r>
           </a:p>
         </p:txBody>
@@ -579,7 +591,19 @@
           <a:lstStyle/>
           <a:p>
             <a:r>
-              <a:t>The average person owns several dead or obsolete devices at any time. We're conditioned — through planned obsolescence, software lock-outs, and repair barriers — to upgrade rather than fix. A new phone launches; the old one becomes slow, then unsupported, then worthless to us. The question isn't whether you threw it away — it's where 'away' actually goes. That's why we're here.</a:t>
+              <a:t>Here's the ugly math. The average smartphone is kept for about 2.5 years before replacement — not because it broke, but because the manufacturer stopped supporting it, the battery degraded past usefulness (and they glued it in so you can't replace it), or the new model made yours feel slow by comparison.</a:t>
+            </a:r>
+          </a:p>
+          <a:p/>
+          <a:p>
+            <a:r>
+              <a:t>This isn't accidental. Planned obsolescence — the deliberate engineering of a product's end-of-life — has been a documented corporate strategy since the 1920s (look up the Phoebus cartel and lightbulbs). Today it manifests as: software updates that brick older hardware, proprietary pentalobe screws, serialized parts that refuse to work if swapped, and warranty stickers that say 'opening this voids everything.'</a:t>
+            </a:r>
+          </a:p>
+          <a:p/>
+          <a:p>
+            <a:r>
+              <a:t>The result: ~1.5 billion phones sold every year. Not because 1.5 billion phones broke.</a:t>
             </a:r>
           </a:p>
         </p:txBody>
@@ -649,7 +673,25 @@
           <a:lstStyle/>
           <a:p>
             <a:r>
-              <a:t>Let's get specific. Across the country — and disproportionately in lower-income neighborhoods and communities of color — improper e-waste disposal is a documented public-health hazard. Lead, mercury, cadmium, and brominated flame retardants leach from discarded electronics into soil and groundwater, causing neurological damage in children and contamination of local water supplies. It starts in the drawer; it ends in the groundwater.</a:t>
+              <a:t>Let's get local. Let's get uncomfortable.</a:t>
+            </a:r>
+          </a:p>
+          <a:p/>
+          <a:p>
+            <a:r>
+              <a:t>According to the EPA, electronic waste constitutes only 2% of what's in American landfills — but accounts for 70% of the heavy metals. Lead from solder joints. Mercury from flat-panel backlights. Cadmium from NiCd batteries. Brominated flame retardants from plastic housings.</a:t>
+            </a:r>
+          </a:p>
+          <a:p/>
+          <a:p>
+            <a:r>
+              <a:t>And here's what makes this an environmental justice issue, not just an environmental issue: the communities that live nearest to landfills and informal recycling sites are disproportionately low-income and communities of color. A 2019 study in Environmental Health Perspectives found blood lead levels in children living within 2km of e-waste processing sites were 30-50% higher than regional averages.</a:t>
+            </a:r>
+          </a:p>
+          <a:p/>
+          <a:p>
+            <a:r>
+              <a:t>This isn't happening 'somewhere else.' It's happening in specific ZIP codes, to specific families, right now.</a:t>
             </a:r>
           </a:p>
         </p:txBody>
@@ -719,7 +761,31 @@
           <a:lstStyle/>
           <a:p>
             <a:r>
-              <a:t>The Right to Repair is a growing legislative and grassroots movement: consumers and independent technicians should have the legal right to fix what they own — with access to parts, tools, and documentation. Manufacturers often use software locks, proprietary screws, and parts-pairing to block independent repair, forcing costly official repairs or replacement. By 2023, over 40 U.S. states had introduced repair legislation. Groups like iFixit, repair cafés, and tool libraries turn frustration into action — one repaired phone at a time.</a:t>
+              <a:t>The Right to Repair movement is the direct, grassroots answer to planned obsolescence.</a:t>
+            </a:r>
+          </a:p>
+          <a:p/>
+          <a:p>
+            <a:r>
+              <a:t>It argues a simple principle: if you bought it, you own it — and you should have the legal right to fix it. That means access to spare parts at fair prices, diagnostic tools and schematics, and freedom from software locks that brick a device when you replace a component.</a:t>
+            </a:r>
+          </a:p>
+          <a:p/>
+          <a:p>
+            <a:r>
+              <a:t>This isn't fringe anymore. By 2023, over 40 U.S. states had introduced some form of repair legislation. The EU passed regulations in 2021 requiring manufacturers to provide spare parts for up to 10 years. Apple — the poster child for anti-repair practices — was forced to launch a Self Service Repair program in 2022 after years of public pressure and FTC scrutiny.</a:t>
+            </a:r>
+          </a:p>
+          <a:p/>
+          <a:p>
+            <a:r>
+              <a:t>On the ground: repair cafes have exploded. There are now over 2,500 registered repair cafes globally, staffed by volunteers who'll fix your toaster, your laptop, your jacket zipper. Community tool libraries lend out iFixit kits. YouTube teardown channels have millions of subscribers.</a:t>
+            </a:r>
+          </a:p>
+          <a:p/>
+          <a:p>
+            <a:r>
+              <a:t>This is what a movement looks like before it wins.</a:t>
             </a:r>
           </a:p>
         </p:txBody>
@@ -789,7 +855,37 @@
           <a:lstStyle/>
           <a:p>
             <a:r>
-              <a:t>According to the Global E-Waste Monitor 2020 — published by the United Nations University and co-authored by Forti, Baldé, Kuehr and Bel — 53.6 million metric tonnes of e-waste were generated globally in 2019 alone, the world's fastest-growing domestic waste stream. Only 17.4% was formally collected and recycled. The rest — over 44 million tonnes — was dumped, burned, or informally traded. The drawer from slide one exists in a billion homes, and almost none of it has a safe place to go.</a:t>
+              <a:t>Numbers time. Let them land.</a:t>
+            </a:r>
+          </a:p>
+          <a:p/>
+          <a:p>
+            <a:r>
+              <a:t>53.6 million metric tonnes. That's how much electronic waste the world generated in 2019 alone, according to the Global E-Waste Monitor 2020 — the most comprehensive study ever conducted on this topic, published by the United Nations University.</a:t>
+            </a:r>
+          </a:p>
+          <a:p/>
+          <a:p>
+            <a:r>
+              <a:t>Of that: only 17.4% was formally collected, tracked, and recycled in an environmentally sound way. The rest — 44.3 million tonnes — was dumped in landfills, burned in open pits, exported under false documentation, or simply lost into informal economies with no environmental oversight.</a:t>
+            </a:r>
+          </a:p>
+          <a:p/>
+          <a:p>
+            <a:r>
+              <a:t>For scale: 44 million tonnes is heavier than the combined weight of every commercial aircraft ever manufactured in human history. Every Boeing. Every Airbus. Every regional jet. All of it. That's ONE YEAR of unrecycled e-waste.</a:t>
+            </a:r>
+          </a:p>
+          <a:p/>
+          <a:p>
+            <a:r>
+              <a:t>And the number is growing at 3-5% annually. By 2030 it's projected to hit 74 million tonnes.</a:t>
+            </a:r>
+          </a:p>
+          <a:p/>
+          <a:p>
+            <a:r>
+              <a:t>The drawer you saw on slide one? It exists in roughly one billion homes worldwide. Almost none of it has somewhere safe to go.</a:t>
             </a:r>
           </a:p>
         </p:txBody>
@@ -859,7 +955,31 @@
           <a:lstStyle/>
           <a:p>
             <a:r>
-              <a:t>E-waste that leaves our homes doesn't vanish. Much of it — despite 'recycling' labels — is exported to developing nations with weaker enforcement. Agbogbloshie in Accra, Ghana is among the world's largest informal processing sites, where workers, many of them children, burn boards and cables to extract copper and gold, inhaling toxic fumes. Guiyu, China recorded groundwater lead levels far above safe limits. This is a system that exports its consequences to those least responsible for creating them.</a:t>
+              <a:t>This is where it goes. This is 'away.'</a:t>
+            </a:r>
+          </a:p>
+          <a:p/>
+          <a:p>
+            <a:r>
+              <a:t>Despite international agreements like the Basel Convention — which explicitly bans the export of hazardous waste from developed to developing nations — e-waste still flows freely through loopholes labeled 'secondhand goods' or 'donations.'</a:t>
+            </a:r>
+          </a:p>
+          <a:p/>
+          <a:p>
+            <a:r>
+              <a:t>Agbogbloshie in Accra, Ghana became infamous as one of the world's largest informal e-waste processing sites. Workers — many of them children as young as 5 — burn insulation off copper wiring, crack open CRT monitors with hammers, and melt solder off circuit boards over open fires. The air is thick with dioxins. A 2011 Blacksmith Institute report ranked it among the world's 10 most polluted places.</a:t>
+            </a:r>
+          </a:p>
+          <a:p/>
+          <a:p>
+            <a:r>
+              <a:t>Guiyu, China processed e-waste for decades until the government cracked down. By then, groundwater lead levels were measured at 190 times WHO safe limits. Miscarriage rates were six times the national average.</a:t>
+            </a:r>
+          </a:p>
+          <a:p/>
+          <a:p>
+            <a:r>
+              <a:t>This is not recycling. This is cost externalization at a civilizational scale. We get the shiny upgrade. They get the cancer.</a:t>
             </a:r>
           </a:p>
         </p:txBody>
@@ -929,7 +1049,56 @@
           <a:lstStyle/>
           <a:p>
             <a:r>
-              <a:t>Here's where the argument crystallizes. Right to Repair isn't merely consumer convenience — it's an environmental systems intervention. As local repair culture grows, aggregate demand for new devices falls. Falling demand pressures manufacturers to build longer-lasting, more repairable products. Less production means less mining of rare-earth minerals like cobalt and lithium — themselves humanitarian and ecological flashpoints — and less end-of-life waste flowing to Agbogbloshie or Guiyu. The local fix IS the global fix.</a:t>
+              <a:t>This is the intellectual core of the argument. This is why repair isn't just a nice consumer-rights thing — it's an environmental systems intervention.</a:t>
+            </a:r>
+          </a:p>
+          <a:p/>
+          <a:p>
+            <a:r>
+              <a:t>Follow the loop:</a:t>
+            </a:r>
+          </a:p>
+          <a:p>
+            <a:r>
+              <a:t>1. Local repair culture grows — repair cafes, independent shops, DIY YouTube culture</a:t>
+            </a:r>
+          </a:p>
+          <a:p>
+            <a:r>
+              <a:t>2. Aggregate demand for new devices drops — people keep phones 4 years instead of 2</a:t>
+            </a:r>
+          </a:p>
+          <a:p>
+            <a:r>
+              <a:t>3. Manufacturers face market pressure — Samsung, Apple see sales plateaus, investor pressure</a:t>
+            </a:r>
+          </a:p>
+          <a:p>
+            <a:r>
+              <a:t>4. Production and mining decrease — less coltan from DRC, less lithium from Chile, less cobalt from child mines</a:t>
+            </a:r>
+          </a:p>
+          <a:p>
+            <a:r>
+              <a:t>5. Global e-waste load reduces — fewer devices manufactured = fewer devices discarded 3 years later</a:t>
+            </a:r>
+          </a:p>
+          <a:p/>
+          <a:p>
+            <a:r>
+              <a:t>And then the loop reinforces: as manufacturers build more repairable products (because the market demands it), repair becomes easier, more people repair, demand drops further.</a:t>
+            </a:r>
+          </a:p>
+          <a:p/>
+          <a:p>
+            <a:r>
+              <a:t>This is not idealism. The EU's Right to Repair regulations are already measurably extending appliance lifespans. France's repairability index — mandatory on all electronics since 2021 — shifted consumer purchasing patterns within 18 months of implementation.</a:t>
+            </a:r>
+          </a:p>
+          <a:p/>
+          <a:p>
+            <a:r>
+              <a:t>The local fix IS the global fix. They are the same conversation.</a:t>
             </a:r>
           </a:p>
         </p:txBody>
@@ -999,7 +1168,57 @@
           <a:lstStyle/>
           <a:p>
             <a:r>
-              <a:t>We opened with a drawer overflowing with dead tech and tangled cables. Imagine it transformed — cables coiled and labeled, only a couple of working devices, a small repair kit in the corner. That transformation is the whole argument in miniature. The drawer in your home connects directly to a landfill down the road and a burning scrapyard across the world. Repair it, reuse it, and demand the right to fix what you own. The local fix is the global fix. Thank you.</a:t>
+              <a:t>We opened with a drawer. Let's close with it.</a:t>
+            </a:r>
+          </a:p>
+          <a:p/>
+          <a:p>
+            <a:r>
+              <a:t>But imagine it different. Imagine opening that drawer and finding: two devices you actually use, cables that are labeled, a small iFixit toolkit, and space. Actual space. Because you didn't replace things that weren't broken. Because when something broke, you fixed it — or someone in your community helped you fix it.</a:t>
+            </a:r>
+          </a:p>
+          <a:p/>
+          <a:p>
+            <a:r>
+              <a:t>That transformation — from overflowing to intentional — is the whole argument in miniature.</a:t>
+            </a:r>
+          </a:p>
+          <a:p/>
+          <a:p>
+            <a:r>
+              <a:t>What you can do, concretely, starting today:</a:t>
+            </a:r>
+          </a:p>
+          <a:p>
+            <a:r>
+              <a:t>- Support right-to-repair legislation in your state (repair.org tracks every bill)</a:t>
+            </a:r>
+          </a:p>
+          <a:p>
+            <a:r>
+              <a:t>- Find your nearest repair cafe (repaircafe.org — there are 2,500+ globally)</a:t>
+            </a:r>
+          </a:p>
+          <a:p>
+            <a:r>
+              <a:t>- When buying new, choose products with high repairability scores (ifixit.com/repairability)</a:t>
+            </a:r>
+          </a:p>
+          <a:p>
+            <a:r>
+              <a:t>- Before replacing a device, search '[device name] iFixit' — you might be surprised what's fixable</a:t>
+            </a:r>
+          </a:p>
+          <a:p/>
+          <a:p>
+            <a:r>
+              <a:t>The drawer in your home connects directly to a landfill down the road and a burning scrapyard across the ocean. But it also connects to the solution. Every device you repair is one less in the waste stream. Every repair is a vote.</a:t>
+            </a:r>
+          </a:p>
+          <a:p/>
+          <a:p>
+            <a:r>
+              <a:t>The local fix is the global fix. Thank you.</a:t>
             </a:r>
           </a:p>
         </p:txBody>
@@ -4039,14 +4258,60 @@
       </p:pic>
       <p:sp>
         <p:nvSpPr>
-          <p:cNvPr id="3" name="TextBox 2"/>
+          <p:cNvPr id="3" name="Rectangle 2"/>
+          <p:cNvSpPr/>
+          <p:nvPr/>
+        </p:nvSpPr>
+        <p:spPr>
+          <a:xfrm>
+            <a:off x="0" y="4389120"/>
+            <a:ext cx="12191695" cy="2468880"/>
+          </a:xfrm>
+          <a:prstGeom prst="rect">
+            <a:avLst/>
+          </a:prstGeom>
+          <a:solidFill>
+            <a:srgbClr val="1C1C1E">
+              <a:alpha val="55000"/>
+            </a:srgbClr>
+          </a:solidFill>
+          <a:ln>
+            <a:noFill/>
+          </a:ln>
+          <a:effectLst/>
+        </p:spPr>
+        <p:style>
+          <a:lnRef idx="1">
+            <a:schemeClr val="accent1"/>
+          </a:lnRef>
+          <a:fillRef idx="3">
+            <a:schemeClr val="accent1"/>
+          </a:fillRef>
+          <a:effectRef idx="2">
+            <a:schemeClr val="accent1"/>
+          </a:effectRef>
+          <a:fontRef idx="minor">
+            <a:schemeClr val="lt1"/>
+          </a:fontRef>
+        </p:style>
+        <p:txBody>
+          <a:bodyPr rtlCol="0" anchor="ctr"/>
+          <a:lstStyle/>
+          <a:p>
+            <a:pPr algn="ctr"/>
+          </a:p>
+        </p:txBody>
+      </p:sp>
+      <p:sp>
+        <p:nvSpPr>
+          <p:cNvPr id="4" name="TextBox 3"/>
           <p:cNvSpPr txBox="1"/>
           <p:nvPr/>
         </p:nvSpPr>
         <p:spPr>
           <a:xfrm>
-            <a:off x="548640" y="4754880"/>
-            <a:ext cx="10058400" cy="1463040"/>
+            <a:off x="640080" y="4480560"/>
+            <a:ext cx="10058400" cy="2103120"/>
           </a:xfrm>
           <a:prstGeom prst="rect">
             <a:avLst/>
@@ -4054,13 +4319,13 @@
           <a:noFill/>
         </p:spPr>
         <p:txBody>
-          <a:bodyPr wrap="square" anchor="b" lIns="0" rIns="0" tIns="0" bIns="0">
+          <a:bodyPr wrap="square" anchor="t" lIns="45720" rIns="0" tIns="0" bIns="0">
             <a:spAutoFit/>
           </a:bodyPr>
           <a:lstStyle/>
           <a:p>
             <a:r>
-              <a:rPr sz="4600" b="1" i="0" spc="200">
+              <a:rPr sz="4800" b="1" i="0" spc="200">
                 <a:solidFill>
                   <a:srgbClr val="FFFFFF"/>
                 </a:solidFill>
@@ -4070,8 +4335,13 @@
             </a:r>
           </a:p>
           <a:p>
-            <a:r>
-              <a:rPr sz="1800" b="0" i="0">
+            <a:pPr>
+              <a:spcBef>
+                <a:spcPts val="600"/>
+              </a:spcBef>
+            </a:pPr>
+            <a:r>
+              <a:rPr sz="2000" b="0" i="0">
                 <a:solidFill>
                   <a:srgbClr val="F5A321"/>
                 </a:solidFill>
@@ -4080,18 +4350,34 @@
               <a:t>you know which one._</a:t>
             </a:r>
           </a:p>
-        </p:txBody>
-      </p:sp>
-      <p:sp>
-        <p:nvSpPr>
-          <p:cNvPr id="4" name="TextBox 3"/>
+          <a:p>
+            <a:pPr>
+              <a:spcBef>
+                <a:spcPts val="1400"/>
+              </a:spcBef>
+            </a:pPr>
+            <a:r>
+              <a:rPr sz="1300" b="0" i="0">
+                <a:solidFill>
+                  <a:srgbClr val="8A8780"/>
+                </a:solidFill>
+                <a:latin typeface="IBM Plex Mono"/>
+              </a:rPr>
+              <a:t>3.4 dead devices per household. Sitting. Waiting. Leaking.</a:t>
+            </a:r>
+          </a:p>
+        </p:txBody>
+      </p:sp>
+      <p:sp>
+        <p:nvSpPr>
+          <p:cNvPr id="5" name="TextBox 4"/>
           <p:cNvSpPr txBox="1"/>
           <p:nvPr/>
         </p:nvSpPr>
         <p:spPr>
           <a:xfrm>
-            <a:off x="11277295" y="6400800"/>
-            <a:ext cx="731520" cy="320040"/>
+            <a:off x="11368735" y="6446520"/>
+            <a:ext cx="640080" cy="274320"/>
           </a:xfrm>
           <a:prstGeom prst="rect">
             <a:avLst/>
@@ -4099,54 +4385,20 @@
           <a:noFill/>
         </p:spPr>
         <p:txBody>
-          <a:bodyPr wrap="square" anchor="t" lIns="0" rIns="0" tIns="0" bIns="0">
+          <a:bodyPr wrap="square" anchor="t" lIns="45720" rIns="0" tIns="0" bIns="0">
             <a:spAutoFit/>
           </a:bodyPr>
           <a:lstStyle/>
           <a:p>
             <a:pPr algn="r"/>
             <a:r>
-              <a:rPr sz="1100" b="0" i="0">
+              <a:rPr sz="1000" b="0" i="0">
                 <a:solidFill>
                   <a:srgbClr val="F5A321"/>
                 </a:solidFill>
                 <a:latin typeface="IBM Plex Mono"/>
               </a:rPr>
               <a:t>01</a:t>
-            </a:r>
-          </a:p>
-        </p:txBody>
-      </p:sp>
-      <p:sp>
-        <p:nvSpPr>
-          <p:cNvPr id="5" name="TextBox 4"/>
-          <p:cNvSpPr txBox="1"/>
-          <p:nvPr/>
-        </p:nvSpPr>
-        <p:spPr>
-          <a:xfrm>
-            <a:off x="274320" y="6492240"/>
-            <a:ext cx="9144000" cy="274320"/>
-          </a:xfrm>
-          <a:prstGeom prst="rect">
-            <a:avLst/>
-          </a:prstGeom>
-          <a:noFill/>
-        </p:spPr>
-        <p:txBody>
-          <a:bodyPr wrap="square" anchor="t" lIns="0" rIns="0" tIns="0" bIns="0">
-            <a:spAutoFit/>
-          </a:bodyPr>
-          <a:lstStyle/>
-          <a:p>
-            <a:r>
-              <a:rPr sz="700" b="0" i="0">
-                <a:solidFill>
-                  <a:srgbClr val="9A9790"/>
-                </a:solidFill>
-                <a:latin typeface="IBM Plex Mono"/>
-              </a:rPr>
-              <a:t>Image: EFTA00001374 - Cluttered workspace filled with electronic equipment cables and boxes on a workbench.jpg — Federal Bureau of Investigation / Public domain via Wikimedia Commons</a:t>
             </a:r>
           </a:p>
         </p:txBody>
@@ -4241,7 +4493,7 @@
           </a:prstGeom>
           <a:solidFill>
             <a:srgbClr val="121214">
-              <a:alpha val="55000"/>
+              <a:alpha val="50000"/>
             </a:srgbClr>
           </a:solidFill>
           <a:ln>
@@ -4279,8 +4531,8 @@
         </p:nvCxnSpPr>
         <p:spPr>
           <a:xfrm>
-            <a:off x="6035040" y="182880"/>
-            <a:ext cx="5669280" cy="6400800"/>
+            <a:off x="6035040" y="137160"/>
+            <a:ext cx="5760720" cy="6583680"/>
           </a:xfrm>
           <a:prstGeom prst="line">
             <a:avLst/>
@@ -4314,8 +4566,8 @@
         </p:nvSpPr>
         <p:spPr>
           <a:xfrm>
-            <a:off x="731520" y="2743200"/>
-            <a:ext cx="10698480" cy="1371600"/>
+            <a:off x="640080" y="2377440"/>
+            <a:ext cx="10972800" cy="2560320"/>
           </a:xfrm>
           <a:prstGeom prst="rect">
             <a:avLst/>
@@ -4323,14 +4575,14 @@
           <a:noFill/>
         </p:spPr>
         <p:txBody>
-          <a:bodyPr wrap="square" anchor="ctr" lIns="0" rIns="0" tIns="0" bIns="0">
+          <a:bodyPr wrap="square" anchor="t" lIns="45720" rIns="0" tIns="0" bIns="0">
             <a:spAutoFit/>
           </a:bodyPr>
           <a:lstStyle/>
           <a:p>
             <a:pPr algn="ctr"/>
             <a:r>
-              <a:rPr sz="3800" b="1" i="0" spc="150">
+              <a:rPr sz="3600" b="1" i="0" spc="140">
                 <a:solidFill>
                   <a:srgbClr val="FFFFFF"/>
                 </a:solidFill>
@@ -4339,6 +4591,38 @@
               <a:t>EVERY UPGRADE LEAVES SOMETHING BEHIND.</a:t>
             </a:r>
           </a:p>
+          <a:p>
+            <a:pPr algn="ctr">
+              <a:spcBef>
+                <a:spcPts val="1800"/>
+              </a:spcBef>
+            </a:pPr>
+            <a:r>
+              <a:rPr sz="1500" b="0" i="0">
+                <a:solidFill>
+                  <a:srgbClr val="F5A321"/>
+                </a:solidFill>
+                <a:latin typeface="IBM Plex Mono"/>
+              </a:rPr>
+              <a:t>Planned obsolescence is not a bug. It's the business model.</a:t>
+            </a:r>
+          </a:p>
+          <a:p>
+            <a:pPr algn="ctr">
+              <a:spcBef>
+                <a:spcPts val="1000"/>
+              </a:spcBef>
+            </a:pPr>
+            <a:r>
+              <a:rPr sz="1200" b="0" i="0">
+                <a:solidFill>
+                  <a:srgbClr val="8A8780"/>
+                </a:solidFill>
+                <a:latin typeface="IBM Plex Mono"/>
+              </a:rPr>
+              <a:t>Average smartphone lifespan: 2.5 years.  Designed lifespan: 7+ years.</a:t>
+            </a:r>
+          </a:p>
         </p:txBody>
       </p:sp>
       <p:sp>
@@ -4349,8 +4633,8 @@
         </p:nvSpPr>
         <p:spPr>
           <a:xfrm>
-            <a:off x="11277295" y="6400800"/>
-            <a:ext cx="731520" cy="320040"/>
+            <a:off x="11368735" y="6446520"/>
+            <a:ext cx="640080" cy="274320"/>
           </a:xfrm>
           <a:prstGeom prst="rect">
             <a:avLst/>
@@ -4358,14 +4642,14 @@
           <a:noFill/>
         </p:spPr>
         <p:txBody>
-          <a:bodyPr wrap="square" anchor="t" lIns="0" rIns="0" tIns="0" bIns="0">
+          <a:bodyPr wrap="square" anchor="t" lIns="45720" rIns="0" tIns="0" bIns="0">
             <a:spAutoFit/>
           </a:bodyPr>
           <a:lstStyle/>
           <a:p>
             <a:pPr algn="r"/>
             <a:r>
-              <a:rPr sz="1100" b="0" i="0">
+              <a:rPr sz="1000" b="0" i="0">
                 <a:solidFill>
                   <a:srgbClr val="F5A321"/>
                 </a:solidFill>
@@ -4418,8 +4702,8 @@
         </p:blipFill>
         <p:spPr>
           <a:xfrm>
-            <a:off x="4693616" y="0"/>
-            <a:ext cx="7498079" cy="6858000"/>
+            <a:off x="4876495" y="0"/>
+            <a:ext cx="7315200" cy="6858000"/>
           </a:xfrm>
           <a:prstGeom prst="rect">
             <a:avLst/>
@@ -4434,8 +4718,8 @@
         </p:nvSpPr>
         <p:spPr>
           <a:xfrm>
-            <a:off x="4684091" y="0"/>
-            <a:ext cx="28575" cy="6858000"/>
+            <a:off x="4864495" y="0"/>
+            <a:ext cx="36000" cy="6858000"/>
           </a:xfrm>
           <a:prstGeom prst="rect">
             <a:avLst/>
@@ -4478,14 +4762,14 @@
         </p:nvSpPr>
         <p:spPr>
           <a:xfrm>
-            <a:off x="502920" y="1097280"/>
-            <a:ext cx="640080" cy="640080"/>
+            <a:off x="502920" y="914400"/>
+            <a:ext cx="594360" cy="594360"/>
           </a:xfrm>
           <a:prstGeom prst="hexagon">
             <a:avLst/>
           </a:prstGeom>
           <a:noFill/>
-          <a:ln w="25400">
+          <a:ln w="27940">
             <a:solidFill>
               <a:srgbClr val="F5A321"/>
             </a:solidFill>
@@ -4522,8 +4806,8 @@
         </p:nvSpPr>
         <p:spPr>
           <a:xfrm>
-            <a:off x="502920" y="2011680"/>
-            <a:ext cx="3840480" cy="2926080"/>
+            <a:off x="502920" y="1828800"/>
+            <a:ext cx="4114800" cy="4389120"/>
           </a:xfrm>
           <a:prstGeom prst="rect">
             <a:avLst/>
@@ -4531,13 +4815,13 @@
           <a:noFill/>
         </p:spPr>
         <p:txBody>
-          <a:bodyPr wrap="square" anchor="t" lIns="0" rIns="0" tIns="0" bIns="0">
+          <a:bodyPr wrap="square" anchor="t" lIns="45720" rIns="0" tIns="0" bIns="0">
             <a:spAutoFit/>
           </a:bodyPr>
           <a:lstStyle/>
           <a:p>
             <a:r>
-              <a:rPr sz="3000" b="1" i="0" spc="120">
+              <a:rPr sz="2800" b="1" i="0" spc="100">
                 <a:solidFill>
                   <a:srgbClr val="F0EDE6"/>
                 </a:solidFill>
@@ -4548,7 +4832,7 @@
           </a:p>
           <a:p>
             <a:r>
-              <a:rPr sz="3000" b="1" i="0" spc="120">
+              <a:rPr sz="2800" b="1" i="0" spc="100">
                 <a:solidFill>
                   <a:srgbClr val="F0EDE6"/>
                 </a:solidFill>
@@ -4559,7 +4843,7 @@
           </a:p>
           <a:p>
             <a:r>
-              <a:rPr sz="3000" b="1" i="0" spc="120">
+              <a:rPr sz="2800" b="1" i="0" spc="100">
                 <a:solidFill>
                   <a:srgbClr val="F5A321"/>
                 </a:solidFill>
@@ -4571,17 +4855,92 @@
           <a:p>
             <a:pPr>
               <a:spcBef>
-                <a:spcPts val="1400"/>
+                <a:spcPts val="1800"/>
               </a:spcBef>
             </a:pPr>
             <a:r>
-              <a:rPr sz="1300" b="0" i="0">
+              <a:rPr sz="1600" b="1" i="0">
                 <a:solidFill>
                   <a:srgbClr val="3DBFB8"/>
                 </a:solidFill>
                 <a:latin typeface="IBM Plex Mono"/>
               </a:rPr>
-              <a:t>lead · mercury · cadmium → soil &amp; groundwater</a:t>
+              <a:t>Pb · Hg · Cd · BFRs</a:t>
+            </a:r>
+          </a:p>
+          <a:p>
+            <a:pPr>
+              <a:spcBef>
+                <a:spcPts val="800"/>
+              </a:spcBef>
+            </a:pPr>
+            <a:r>
+              <a:rPr sz="1200" b="0" i="0">
+                <a:solidFill>
+                  <a:srgbClr val="F0EDE6"/>
+                </a:solidFill>
+                <a:latin typeface="IBM Plex Mono"/>
+              </a:rPr>
+              <a:t>These aren't abstract chemicals.</a:t>
+            </a:r>
+          </a:p>
+          <a:p>
+            <a:pPr>
+              <a:spcBef>
+                <a:spcPts val="400"/>
+              </a:spcBef>
+            </a:pPr>
+            <a:r>
+              <a:rPr sz="1200" b="0" i="0">
+                <a:solidFill>
+                  <a:srgbClr val="F0EDE6"/>
+                </a:solidFill>
+                <a:latin typeface="IBM Plex Mono"/>
+              </a:rPr>
+              <a:t>They're in the soil. The water.</a:t>
+            </a:r>
+          </a:p>
+          <a:p>
+            <a:pPr>
+              <a:spcBef>
+                <a:spcPts val="400"/>
+              </a:spcBef>
+            </a:pPr>
+            <a:r>
+              <a:rPr sz="1200" b="0" i="1">
+                <a:solidFill>
+                  <a:srgbClr val="F5A321"/>
+                </a:solidFill>
+                <a:latin typeface="IBM Plex Mono"/>
+              </a:rPr>
+              <a:t>The kids playing outside.</a:t>
+            </a:r>
+          </a:p>
+          <a:p>
+            <a:pPr>
+              <a:spcBef>
+                <a:spcPts val="1600"/>
+              </a:spcBef>
+            </a:pPr>
+            <a:r>
+              <a:rPr sz="1100" b="0" i="0">
+                <a:solidFill>
+                  <a:srgbClr val="8A8780"/>
+                </a:solidFill>
+                <a:latin typeface="IBM Plex Mono"/>
+              </a:rPr>
+              <a:t>70% of heavy metals in U.S. landfills</a:t>
+            </a:r>
+          </a:p>
+          <a:p>
+            <a:r>
+              <a:rPr sz="1100" b="0" i="0">
+                <a:solidFill>
+                  <a:srgbClr val="8A8780"/>
+                </a:solidFill>
+                <a:latin typeface="IBM Plex Mono"/>
+              </a:rPr>
+              <a:t>come from discarded electronics.</a:t>
             </a:r>
           </a:p>
         </p:txBody>
@@ -4594,8 +4953,8 @@
         </p:nvSpPr>
         <p:spPr>
           <a:xfrm>
-            <a:off x="11277295" y="6400800"/>
-            <a:ext cx="731520" cy="320040"/>
+            <a:off x="11368735" y="6446520"/>
+            <a:ext cx="640080" cy="274320"/>
           </a:xfrm>
           <a:prstGeom prst="rect">
             <a:avLst/>
@@ -4603,54 +4962,20 @@
           <a:noFill/>
         </p:spPr>
         <p:txBody>
-          <a:bodyPr wrap="square" anchor="t" lIns="0" rIns="0" tIns="0" bIns="0">
+          <a:bodyPr wrap="square" anchor="t" lIns="45720" rIns="0" tIns="0" bIns="0">
             <a:spAutoFit/>
           </a:bodyPr>
           <a:lstStyle/>
           <a:p>
             <a:pPr algn="r"/>
             <a:r>
-              <a:rPr sz="1100" b="0" i="0">
+              <a:rPr sz="1000" b="0" i="0">
                 <a:solidFill>
                   <a:srgbClr val="F5A321"/>
                 </a:solidFill>
                 <a:latin typeface="IBM Plex Mono"/>
               </a:rPr>
               <a:t>03</a:t>
-            </a:r>
-          </a:p>
-        </p:txBody>
-      </p:sp>
-      <p:sp>
-        <p:nvSpPr>
-          <p:cNvPr id="7" name="TextBox 6"/>
-          <p:cNvSpPr txBox="1"/>
-          <p:nvPr/>
-        </p:nvSpPr>
-        <p:spPr>
-          <a:xfrm>
-            <a:off x="274320" y="6492240"/>
-            <a:ext cx="9144000" cy="274320"/>
-          </a:xfrm>
-          <a:prstGeom prst="rect">
-            <a:avLst/>
-          </a:prstGeom>
-          <a:noFill/>
-        </p:spPr>
-        <p:txBody>
-          <a:bodyPr wrap="square" anchor="t" lIns="0" rIns="0" tIns="0" bIns="0">
-            <a:spAutoFit/>
-          </a:bodyPr>
-          <a:lstStyle/>
-          <a:p>
-            <a:r>
-              <a:rPr sz="700" b="0" i="0">
-                <a:solidFill>
-                  <a:srgbClr val="9A9790"/>
-                </a:solidFill>
-                <a:latin typeface="IBM Plex Mono"/>
-              </a:rPr>
-              <a:t>Image: DFC 4508 A narrow pathway winds through a cluttered scrapyard piled high with discarded metal plastic pipes and other tangled debris.jpg — PattayaPatrol / CC BY-SA 4.0 via Wikimedia Commons</a:t>
             </a:r>
           </a:p>
         </p:txBody>
@@ -4713,15 +5038,15 @@
         </p:nvSpPr>
         <p:spPr>
           <a:xfrm>
-            <a:off x="457200" y="548640"/>
-            <a:ext cx="5852160" cy="3108960"/>
+            <a:off x="365760" y="457200"/>
+            <a:ext cx="6400800" cy="3840480"/>
           </a:xfrm>
           <a:prstGeom prst="rect">
             <a:avLst/>
           </a:prstGeom>
           <a:solidFill>
             <a:srgbClr val="3DBFB8">
-              <a:alpha val="62000"/>
+              <a:alpha val="65000"/>
             </a:srgbClr>
           </a:solidFill>
           <a:ln>
@@ -4759,8 +5084,8 @@
         </p:nvSpPr>
         <p:spPr>
           <a:xfrm>
-            <a:off x="777240" y="868680"/>
-            <a:ext cx="5303520" cy="2743200"/>
+            <a:off x="731520" y="731520"/>
+            <a:ext cx="5852160" cy="3474720"/>
           </a:xfrm>
           <a:prstGeom prst="rect">
             <a:avLst/>
@@ -4768,13 +5093,13 @@
           <a:noFill/>
         </p:spPr>
         <p:txBody>
-          <a:bodyPr wrap="square" anchor="t" lIns="0" rIns="0" tIns="0" bIns="0">
+          <a:bodyPr wrap="square" anchor="t" lIns="45720" rIns="0" tIns="0" bIns="0">
             <a:spAutoFit/>
           </a:bodyPr>
           <a:lstStyle/>
           <a:p>
             <a:r>
-              <a:rPr sz="3400" b="1" i="0" spc="120">
+              <a:rPr sz="3600" b="1" i="0" spc="120">
                 <a:solidFill>
                   <a:srgbClr val="FFFFFF"/>
                 </a:solidFill>
@@ -4785,7 +5110,7 @@
           </a:p>
           <a:p>
             <a:r>
-              <a:rPr sz="3400" b="1" i="0" spc="120">
+              <a:rPr sz="3600" b="1" i="0" spc="120">
                 <a:solidFill>
                   <a:srgbClr val="FFFFFF"/>
                 </a:solidFill>
@@ -4796,7 +5121,7 @@
           </a:p>
           <a:p>
             <a:r>
-              <a:rPr sz="3400" b="1" i="0" spc="120">
+              <a:rPr sz="3600" b="1" i="0" spc="120">
                 <a:solidFill>
                   <a:srgbClr val="FFFFFF"/>
                 </a:solidFill>
@@ -4808,19 +5133,67 @@
           <a:p>
             <a:pPr>
               <a:spcBef>
-                <a:spcPts val="1200"/>
+                <a:spcPts val="1600"/>
               </a:spcBef>
             </a:pPr>
             <a:r>
-              <a:rPr sz="1400" b="0" i="0">
-                <a:solidFill>
-                  <a:srgbClr val="102A28"/>
+              <a:rPr sz="1500" b="0" i="0">
+                <a:solidFill>
+                  <a:srgbClr val="0A2220"/>
                 </a:solidFill>
                 <a:latin typeface="IBM Plex Mono"/>
               </a:rPr>
               <a:t>the repair movement begins here.</a:t>
             </a:r>
           </a:p>
+          <a:p>
+            <a:pPr>
+              <a:spcBef>
+                <a:spcPts val="1400"/>
+              </a:spcBef>
+            </a:pPr>
+            <a:r>
+              <a:rPr sz="1200" b="0" i="0">
+                <a:solidFill>
+                  <a:srgbClr val="FFFFFF"/>
+                </a:solidFill>
+                <a:latin typeface="IBM Plex Mono"/>
+              </a:rPr>
+              <a:t>40+ U.S. states introduced repair bills (2023)</a:t>
+            </a:r>
+          </a:p>
+          <a:p>
+            <a:pPr>
+              <a:spcBef>
+                <a:spcPts val="400"/>
+              </a:spcBef>
+            </a:pPr>
+            <a:r>
+              <a:rPr sz="1200" b="0" i="0">
+                <a:solidFill>
+                  <a:srgbClr val="FFFFFF"/>
+                </a:solidFill>
+                <a:latin typeface="IBM Plex Mono"/>
+              </a:rPr>
+              <a:t>EU mandated 10-year spare parts access (2021)</a:t>
+            </a:r>
+          </a:p>
+          <a:p>
+            <a:pPr>
+              <a:spcBef>
+                <a:spcPts val="400"/>
+              </a:spcBef>
+            </a:pPr>
+            <a:r>
+              <a:rPr sz="1200" b="0" i="0">
+                <a:solidFill>
+                  <a:srgbClr val="FFFFFF"/>
+                </a:solidFill>
+                <a:latin typeface="IBM Plex Mono"/>
+              </a:rPr>
+              <a:t>iFixit repairability scores now influence FTC action</a:t>
+            </a:r>
+          </a:p>
         </p:txBody>
       </p:sp>
       <p:sp>
@@ -4831,8 +5204,8 @@
         </p:nvSpPr>
         <p:spPr>
           <a:xfrm>
-            <a:off x="11277295" y="6400800"/>
-            <a:ext cx="731520" cy="320040"/>
+            <a:off x="11368735" y="6446520"/>
+            <a:ext cx="640080" cy="274320"/>
           </a:xfrm>
           <a:prstGeom prst="rect">
             <a:avLst/>
@@ -4840,54 +5213,20 @@
           <a:noFill/>
         </p:spPr>
         <p:txBody>
-          <a:bodyPr wrap="square" anchor="t" lIns="0" rIns="0" tIns="0" bIns="0">
+          <a:bodyPr wrap="square" anchor="t" lIns="45720" rIns="0" tIns="0" bIns="0">
             <a:spAutoFit/>
           </a:bodyPr>
           <a:lstStyle/>
           <a:p>
             <a:pPr algn="r"/>
             <a:r>
-              <a:rPr sz="1100" b="0" i="0">
+              <a:rPr sz="1000" b="0" i="0">
                 <a:solidFill>
                   <a:srgbClr val="F5A321"/>
                 </a:solidFill>
                 <a:latin typeface="IBM Plex Mono"/>
               </a:rPr>
               <a:t>04</a:t>
-            </a:r>
-          </a:p>
-        </p:txBody>
-      </p:sp>
-      <p:sp>
-        <p:nvSpPr>
-          <p:cNvPr id="6" name="TextBox 5"/>
-          <p:cNvSpPr txBox="1"/>
-          <p:nvPr/>
-        </p:nvSpPr>
-        <p:spPr>
-          <a:xfrm>
-            <a:off x="274320" y="6492240"/>
-            <a:ext cx="9144000" cy="274320"/>
-          </a:xfrm>
-          <a:prstGeom prst="rect">
-            <a:avLst/>
-          </a:prstGeom>
-          <a:noFill/>
-        </p:spPr>
-        <p:txBody>
-          <a:bodyPr wrap="square" anchor="t" lIns="0" rIns="0" tIns="0" bIns="0">
-            <a:spAutoFit/>
-          </a:bodyPr>
-          <a:lstStyle/>
-          <a:p>
-            <a:r>
-              <a:rPr sz="700" b="0" i="0">
-                <a:solidFill>
-                  <a:srgbClr val="9A9790"/>
-                </a:solidFill>
-                <a:latin typeface="IBM Plex Mono"/>
-              </a:rPr>
-              <a:t>Image: Repair Lab (48115787881).jpg — Redaktion NdW / CC BY 2.0 via Wikimedia Commons</a:t>
             </a:r>
           </a:p>
         </p:txBody>
@@ -4926,8 +5265,8 @@
         </p:nvSpPr>
         <p:spPr>
           <a:xfrm>
-            <a:off x="365760" y="640080"/>
-            <a:ext cx="11521440" cy="2194560"/>
+            <a:off x="365760" y="365760"/>
+            <a:ext cx="11430000" cy="2377440"/>
           </a:xfrm>
           <a:prstGeom prst="rect">
             <a:avLst/>
@@ -4935,7 +5274,7 @@
           <a:noFill/>
         </p:spPr>
         <p:txBody>
-          <a:bodyPr wrap="square" anchor="t" lIns="0" rIns="0" tIns="0" bIns="0">
+          <a:bodyPr wrap="square" anchor="t" lIns="45720" rIns="0" tIns="0" bIns="0">
             <a:spAutoFit/>
           </a:bodyPr>
           <a:lstStyle/>
@@ -4960,8 +5299,8 @@
         </p:nvSpPr>
         <p:spPr>
           <a:xfrm>
-            <a:off x="457200" y="2743200"/>
-            <a:ext cx="10972800" cy="548640"/>
+            <a:off x="457200" y="2606040"/>
+            <a:ext cx="10972800" cy="731520"/>
           </a:xfrm>
           <a:prstGeom prst="rect">
             <a:avLst/>
@@ -4969,19 +5308,35 @@
           <a:noFill/>
         </p:spPr>
         <p:txBody>
-          <a:bodyPr wrap="square" anchor="t" lIns="0" rIns="0" tIns="0" bIns="0">
+          <a:bodyPr wrap="square" anchor="t" lIns="45720" rIns="0" tIns="0" bIns="0">
             <a:spAutoFit/>
           </a:bodyPr>
           <a:lstStyle/>
           <a:p>
             <a:r>
-              <a:rPr sz="1600" b="0" i="0" spc="120">
+              <a:rPr sz="1700" b="0" i="0" spc="140">
                 <a:solidFill>
                   <a:srgbClr val="F0EDE6"/>
                 </a:solidFill>
                 <a:latin typeface="IBM Plex Mono"/>
               </a:rPr>
-              <a:t>METRIC TONNES OF E-WASTE GENERATED GLOBALLY (2019)</a:t>
+              <a:t>METRIC TONNES. ONE YEAR. ONE PLANET.</a:t>
+            </a:r>
+          </a:p>
+          <a:p>
+            <a:pPr>
+              <a:spcBef>
+                <a:spcPts val="600"/>
+              </a:spcBef>
+            </a:pPr>
+            <a:r>
+              <a:rPr sz="1300" b="0" i="0">
+                <a:solidFill>
+                  <a:srgbClr val="3DBFB8"/>
+                </a:solidFill>
+                <a:latin typeface="IBM Plex Mono"/>
+              </a:rPr>
+              <a:t>The fastest-growing waste stream on Earth.</a:t>
             </a:r>
           </a:p>
         </p:txBody>
@@ -4994,8 +5349,8 @@
         </p:nvSpPr>
         <p:spPr>
           <a:xfrm>
-            <a:off x="548640" y="3931920"/>
-            <a:ext cx="8412480" cy="502920"/>
+            <a:off x="548640" y="3749039"/>
+            <a:ext cx="8412480" cy="457200"/>
           </a:xfrm>
           <a:prstGeom prst="rect">
             <a:avLst/>
@@ -5038,8 +5393,8 @@
         </p:nvSpPr>
         <p:spPr>
           <a:xfrm>
-            <a:off x="9098280" y="3931920"/>
-            <a:ext cx="2743200" cy="502920"/>
+            <a:off x="9144000" y="3749039"/>
+            <a:ext cx="2926080" cy="457200"/>
           </a:xfrm>
           <a:prstGeom prst="rect">
             <a:avLst/>
@@ -5047,19 +5402,19 @@
           <a:noFill/>
         </p:spPr>
         <p:txBody>
-          <a:bodyPr wrap="square" anchor="ctr" lIns="0" rIns="0" tIns="0" bIns="0">
+          <a:bodyPr wrap="square" anchor="ctr" lIns="45720" rIns="0" tIns="0" bIns="0">
             <a:spAutoFit/>
           </a:bodyPr>
           <a:lstStyle/>
           <a:p>
             <a:r>
-              <a:rPr sz="1200" b="0" i="0">
+              <a:rPr sz="1100" b="0" i="0">
                 <a:solidFill>
                   <a:srgbClr val="F5A321"/>
                 </a:solidFill>
                 <a:latin typeface="IBM Plex Mono"/>
               </a:rPr>
-              <a:t>generated  53.6 Mt</a:t>
+              <a:t>generated — 53.6 Mt</a:t>
             </a:r>
           </a:p>
         </p:txBody>
@@ -5072,8 +5427,8 @@
         </p:nvSpPr>
         <p:spPr>
           <a:xfrm>
-            <a:off x="548640" y="4663440"/>
-            <a:ext cx="1463771" cy="502920"/>
+            <a:off x="548640" y="4434839"/>
+            <a:ext cx="1463771" cy="457200"/>
           </a:xfrm>
           <a:prstGeom prst="rect">
             <a:avLst/>
@@ -5116,8 +5471,8 @@
         </p:nvSpPr>
         <p:spPr>
           <a:xfrm>
-            <a:off x="2149571" y="4663440"/>
-            <a:ext cx="5486400" cy="502920"/>
+            <a:off x="2195291" y="4434839"/>
+            <a:ext cx="5486400" cy="457200"/>
           </a:xfrm>
           <a:prstGeom prst="rect">
             <a:avLst/>
@@ -5125,33 +5480,78 @@
           <a:noFill/>
         </p:spPr>
         <p:txBody>
-          <a:bodyPr wrap="square" anchor="ctr" lIns="0" rIns="0" tIns="0" bIns="0">
+          <a:bodyPr wrap="square" anchor="ctr" lIns="45720" rIns="0" tIns="0" bIns="0">
             <a:spAutoFit/>
           </a:bodyPr>
           <a:lstStyle/>
           <a:p>
             <a:r>
-              <a:rPr sz="1200" b="0" i="0">
+              <a:rPr sz="1100" b="0" i="0">
                 <a:solidFill>
                   <a:srgbClr val="3DBFB8"/>
                 </a:solidFill>
                 <a:latin typeface="IBM Plex Mono"/>
               </a:rPr>
-              <a:t>formally recycled  only 17.4%</a:t>
-            </a:r>
-          </a:p>
-        </p:txBody>
-      </p:sp>
-      <p:sp>
-        <p:nvSpPr>
-          <p:cNvPr id="8" name="Rounded Rectangle 7"/>
+              <a:t>recycled — only 17.4%</a:t>
+            </a:r>
+          </a:p>
+        </p:txBody>
+      </p:sp>
+      <p:sp>
+        <p:nvSpPr>
+          <p:cNvPr id="8" name="TextBox 7"/>
+          <p:cNvSpPr txBox="1"/>
+          <p:nvPr/>
+        </p:nvSpPr>
+        <p:spPr>
+          <a:xfrm>
+            <a:off x="548640" y="5120640"/>
+            <a:ext cx="8229600" cy="640080"/>
+          </a:xfrm>
+          <a:prstGeom prst="rect">
+            <a:avLst/>
+          </a:prstGeom>
+          <a:noFill/>
+        </p:spPr>
+        <p:txBody>
+          <a:bodyPr wrap="square" anchor="t" lIns="45720" rIns="0" tIns="0" bIns="0">
+            <a:spAutoFit/>
+          </a:bodyPr>
+          <a:lstStyle/>
+          <a:p>
+            <a:r>
+              <a:rPr sz="1200" b="0" i="0">
+                <a:solidFill>
+                  <a:srgbClr val="8A8780"/>
+                </a:solidFill>
+                <a:latin typeface="IBM Plex Mono"/>
+              </a:rPr>
+              <a:t>That gap — 44 million tonnes — is heavier than every</a:t>
+            </a:r>
+          </a:p>
+          <a:p>
+            <a:r>
+              <a:rPr sz="1200" b="0" i="1">
+                <a:solidFill>
+                  <a:srgbClr val="F0EDE6"/>
+                </a:solidFill>
+                <a:latin typeface="IBM Plex Mono"/>
+              </a:rPr>
+              <a:t>commercial aircraft ever built. Combined.</a:t>
+            </a:r>
+          </a:p>
+        </p:txBody>
+      </p:sp>
+      <p:sp>
+        <p:nvSpPr>
+          <p:cNvPr id="9" name="Rounded Rectangle 8"/>
           <p:cNvSpPr/>
           <p:nvPr/>
         </p:nvSpPr>
         <p:spPr>
           <a:xfrm>
-            <a:off x="8138160" y="5394960"/>
-            <a:ext cx="3749039" cy="1143000"/>
+            <a:off x="8046720" y="5486400"/>
+            <a:ext cx="3840480" cy="1097280"/>
           </a:xfrm>
           <a:prstGeom prst="roundRect">
             <a:avLst/>
@@ -5188,14 +5588,14 @@
       </p:sp>
       <p:sp>
         <p:nvSpPr>
-          <p:cNvPr id="9" name="TextBox 8"/>
+          <p:cNvPr id="10" name="TextBox 9"/>
           <p:cNvSpPr txBox="1"/>
           <p:nvPr/>
         </p:nvSpPr>
         <p:spPr>
           <a:xfrm>
-            <a:off x="8321040" y="5504688"/>
-            <a:ext cx="3383280" cy="914400"/>
+            <a:off x="8229600" y="5577840"/>
+            <a:ext cx="3474720" cy="914400"/>
           </a:xfrm>
           <a:prstGeom prst="rect">
             <a:avLst/>
@@ -5203,7 +5603,7 @@
           <a:noFill/>
         </p:spPr>
         <p:txBody>
-          <a:bodyPr wrap="square" anchor="t" lIns="0" rIns="0" tIns="0" bIns="0">
+          <a:bodyPr wrap="square" anchor="t" lIns="45720" rIns="0" tIns="0" bIns="0">
             <a:spAutoFit/>
           </a:bodyPr>
           <a:lstStyle/>
@@ -5215,43 +5615,43 @@
                 </a:solidFill>
                 <a:latin typeface="IBM Plex Mono"/>
               </a:rPr>
-              <a:t>SOURCE — Global E-Waste Monitor 2020</a:t>
-            </a:r>
-          </a:p>
-          <a:p>
-            <a:r>
-              <a:rPr sz="900" b="0" i="0">
-                <a:solidFill>
-                  <a:srgbClr val="444446"/>
+              <a:t>Global E-Waste Monitor 2020</a:t>
+            </a:r>
+          </a:p>
+          <a:p>
+            <a:r>
+              <a:rPr sz="850" b="0" i="0">
+                <a:solidFill>
+                  <a:srgbClr val="555557"/>
                 </a:solidFill>
                 <a:latin typeface="IBM Plex Mono"/>
               </a:rPr>
-              <a:t>Forti, Baldé, Kuehr &amp; Bel</a:t>
-            </a:r>
-          </a:p>
-          <a:p>
-            <a:r>
-              <a:rPr sz="900" b="0" i="0">
-                <a:solidFill>
-                  <a:srgbClr val="444446"/>
+              <a:t>Forti, Balde, Kuehr &amp; Bel</a:t>
+            </a:r>
+          </a:p>
+          <a:p>
+            <a:r>
+              <a:rPr sz="850" b="0" i="0">
+                <a:solidFill>
+                  <a:srgbClr val="555557"/>
                 </a:solidFill>
                 <a:latin typeface="IBM Plex Mono"/>
               </a:rPr>
-              <a:t>UNU/UNITAR-SCYCLE · ITU · ISWA</a:t>
-            </a:r>
-          </a:p>
-        </p:txBody>
-      </p:sp>
-      <p:sp>
-        <p:nvSpPr>
-          <p:cNvPr id="10" name="TextBox 9"/>
+              <a:t>UNU/UNITAR-SCYCLE | ITU | ISWA</a:t>
+            </a:r>
+          </a:p>
+        </p:txBody>
+      </p:sp>
+      <p:sp>
+        <p:nvSpPr>
+          <p:cNvPr id="11" name="TextBox 10"/>
           <p:cNvSpPr txBox="1"/>
           <p:nvPr/>
         </p:nvSpPr>
         <p:spPr>
           <a:xfrm>
-            <a:off x="11277295" y="6400800"/>
-            <a:ext cx="731520" cy="320040"/>
+            <a:off x="11368735" y="6446520"/>
+            <a:ext cx="640080" cy="274320"/>
           </a:xfrm>
           <a:prstGeom prst="rect">
             <a:avLst/>
@@ -5259,14 +5659,14 @@
           <a:noFill/>
         </p:spPr>
         <p:txBody>
-          <a:bodyPr wrap="square" anchor="t" lIns="0" rIns="0" tIns="0" bIns="0">
+          <a:bodyPr wrap="square" anchor="t" lIns="45720" rIns="0" tIns="0" bIns="0">
             <a:spAutoFit/>
           </a:bodyPr>
           <a:lstStyle/>
           <a:p>
             <a:pPr algn="r"/>
             <a:r>
-              <a:rPr sz="1100" b="0" i="0">
+              <a:rPr sz="1000" b="0" i="0">
                 <a:solidFill>
                   <a:srgbClr val="F5A321"/>
                 </a:solidFill>
@@ -5335,8 +5735,8 @@
         </p:nvSpPr>
         <p:spPr>
           <a:xfrm>
-            <a:off x="548640" y="502920"/>
-            <a:ext cx="8686800" cy="1463040"/>
+            <a:off x="548640" y="365760"/>
+            <a:ext cx="9144000" cy="2011680"/>
           </a:xfrm>
           <a:prstGeom prst="rect">
             <a:avLst/>
@@ -5344,7 +5744,7 @@
           <a:noFill/>
         </p:spPr>
         <p:txBody>
-          <a:bodyPr wrap="square" anchor="t" lIns="0" rIns="0" tIns="0" bIns="0">
+          <a:bodyPr wrap="square" anchor="t" lIns="45720" rIns="0" tIns="0" bIns="0">
             <a:spAutoFit/>
           </a:bodyPr>
           <a:lstStyle/>
@@ -5374,14 +5774,60 @@
       </p:sp>
       <p:sp>
         <p:nvSpPr>
-          <p:cNvPr id="4" name="TextBox 3"/>
+          <p:cNvPr id="4" name="Rectangle 3"/>
+          <p:cNvSpPr/>
+          <p:nvPr/>
+        </p:nvSpPr>
+        <p:spPr>
+          <a:xfrm>
+            <a:off x="0" y="5120640"/>
+            <a:ext cx="12191695" cy="1737360"/>
+          </a:xfrm>
+          <a:prstGeom prst="rect">
+            <a:avLst/>
+          </a:prstGeom>
+          <a:solidFill>
+            <a:srgbClr val="1C1C1E">
+              <a:alpha val="72000"/>
+            </a:srgbClr>
+          </a:solidFill>
+          <a:ln>
+            <a:noFill/>
+          </a:ln>
+          <a:effectLst/>
+        </p:spPr>
+        <p:style>
+          <a:lnRef idx="1">
+            <a:schemeClr val="accent1"/>
+          </a:lnRef>
+          <a:fillRef idx="3">
+            <a:schemeClr val="accent1"/>
+          </a:fillRef>
+          <a:effectRef idx="2">
+            <a:schemeClr val="accent1"/>
+          </a:effectRef>
+          <a:fontRef idx="minor">
+            <a:schemeClr val="lt1"/>
+          </a:fontRef>
+        </p:style>
+        <p:txBody>
+          <a:bodyPr rtlCol="0" anchor="ctr"/>
+          <a:lstStyle/>
+          <a:p>
+            <a:pPr algn="ctr"/>
+          </a:p>
+        </p:txBody>
+      </p:sp>
+      <p:sp>
+        <p:nvSpPr>
+          <p:cNvPr id="5" name="TextBox 4"/>
           <p:cNvSpPr txBox="1"/>
           <p:nvPr/>
         </p:nvSpPr>
         <p:spPr>
           <a:xfrm>
-            <a:off x="548640" y="5852160"/>
-            <a:ext cx="10058400" cy="457200"/>
+            <a:off x="548640" y="5257800"/>
+            <a:ext cx="10972800" cy="1463040"/>
           </a:xfrm>
           <a:prstGeom prst="rect">
             <a:avLst/>
@@ -5389,33 +5835,92 @@
           <a:noFill/>
         </p:spPr>
         <p:txBody>
-          <a:bodyPr wrap="square" anchor="t" lIns="0" rIns="0" tIns="0" bIns="0">
+          <a:bodyPr wrap="square" anchor="t" lIns="45720" rIns="0" tIns="0" bIns="0">
             <a:spAutoFit/>
           </a:bodyPr>
           <a:lstStyle/>
           <a:p>
             <a:r>
-              <a:rPr sz="1300" b="0" i="0">
-                <a:solidFill>
-                  <a:srgbClr val="F0EDE6"/>
+              <a:rPr sz="1400" b="1" i="0">
+                <a:solidFill>
+                  <a:srgbClr val="F5A321"/>
                 </a:solidFill>
                 <a:latin typeface="IBM Plex Mono"/>
               </a:rPr>
-              <a:t>Agbogbloshie, GH  ·  Guiyu, CN  ·  New Delhi, IN  —  the world's e-waste sinks</a:t>
-            </a:r>
-          </a:p>
-        </p:txBody>
-      </p:sp>
-      <p:sp>
-        <p:nvSpPr>
-          <p:cNvPr id="5" name="TextBox 4"/>
+              <a:t>Agbogbloshie, Ghana</a:t>
+            </a:r>
+            <a:r>
+              <a:rPr sz="1200" b="0">
+                <a:solidFill>
+                  <a:srgbClr val="F0EDE6"/>
+                </a:solidFill>
+                <a:latin typeface="IBM Plex Mono"/>
+              </a:rPr>
+              <a:t>  —  children burn circuit boards for copper.  No masks.  No gloves.</a:t>
+            </a:r>
+          </a:p>
+          <a:p>
+            <a:pPr>
+              <a:spcBef>
+                <a:spcPts val="600"/>
+              </a:spcBef>
+            </a:pPr>
+            <a:r>
+              <a:rPr sz="1400" b="1" i="0">
+                <a:solidFill>
+                  <a:srgbClr val="F5A321"/>
+                </a:solidFill>
+                <a:latin typeface="IBM Plex Mono"/>
+              </a:rPr>
+              <a:t>Guiyu, China</a:t>
+            </a:r>
+            <a:r>
+              <a:rPr sz="1200" b="0">
+                <a:solidFill>
+                  <a:srgbClr val="F0EDE6"/>
+                </a:solidFill>
+                <a:latin typeface="IBM Plex Mono"/>
+              </a:rPr>
+              <a:t>  —  groundwater lead: 190x safe limits.  Cancer clusters documented.</a:t>
+            </a:r>
+          </a:p>
+          <a:p>
+            <a:pPr>
+              <a:spcBef>
+                <a:spcPts val="600"/>
+              </a:spcBef>
+            </a:pPr>
+            <a:r>
+              <a:rPr sz="1400" b="1" i="0">
+                <a:solidFill>
+                  <a:srgbClr val="F5A321"/>
+                </a:solidFill>
+                <a:latin typeface="IBM Plex Mono"/>
+              </a:rPr>
+              <a:t>New Delhi, India</a:t>
+            </a:r>
+            <a:r>
+              <a:rPr sz="1200" b="0">
+                <a:solidFill>
+                  <a:srgbClr val="F0EDE6"/>
+                </a:solidFill>
+                <a:latin typeface="IBM Plex Mono"/>
+              </a:rPr>
+              <a:t>  —  acid baths in residential streets to extract gold from motherboards.</a:t>
+            </a:r>
+          </a:p>
+        </p:txBody>
+      </p:sp>
+      <p:sp>
+        <p:nvSpPr>
+          <p:cNvPr id="6" name="TextBox 5"/>
           <p:cNvSpPr txBox="1"/>
           <p:nvPr/>
         </p:nvSpPr>
         <p:spPr>
           <a:xfrm>
-            <a:off x="11277295" y="6400800"/>
-            <a:ext cx="731520" cy="320040"/>
+            <a:off x="11368735" y="6446520"/>
+            <a:ext cx="640080" cy="274320"/>
           </a:xfrm>
           <a:prstGeom prst="rect">
             <a:avLst/>
@@ -5423,54 +5928,20 @@
           <a:noFill/>
         </p:spPr>
         <p:txBody>
-          <a:bodyPr wrap="square" anchor="t" lIns="0" rIns="0" tIns="0" bIns="0">
+          <a:bodyPr wrap="square" anchor="t" lIns="45720" rIns="0" tIns="0" bIns="0">
             <a:spAutoFit/>
           </a:bodyPr>
           <a:lstStyle/>
           <a:p>
             <a:pPr algn="r"/>
             <a:r>
-              <a:rPr sz="1100" b="0" i="0">
+              <a:rPr sz="1000" b="0" i="0">
                 <a:solidFill>
                   <a:srgbClr val="F5A321"/>
                 </a:solidFill>
                 <a:latin typeface="IBM Plex Mono"/>
               </a:rPr>
               <a:t>06</a:t>
-            </a:r>
-          </a:p>
-        </p:txBody>
-      </p:sp>
-      <p:sp>
-        <p:nvSpPr>
-          <p:cNvPr id="6" name="TextBox 5"/>
-          <p:cNvSpPr txBox="1"/>
-          <p:nvPr/>
-        </p:nvSpPr>
-        <p:spPr>
-          <a:xfrm>
-            <a:off x="274320" y="6492240"/>
-            <a:ext cx="9144000" cy="274320"/>
-          </a:xfrm>
-          <a:prstGeom prst="rect">
-            <a:avLst/>
-          </a:prstGeom>
-          <a:noFill/>
-        </p:spPr>
-        <p:txBody>
-          <a:bodyPr wrap="square" anchor="t" lIns="0" rIns="0" tIns="0" bIns="0">
-            <a:spAutoFit/>
-          </a:bodyPr>
-          <a:lstStyle/>
-          <a:p>
-            <a:r>
-              <a:rPr sz="700" b="0" i="0">
-                <a:solidFill>
-                  <a:srgbClr val="9A9790"/>
-                </a:solidFill>
-                <a:latin typeface="IBM Plex Mono"/>
-              </a:rPr>
-              <a:t>Image: Agbogbloshie, Ghana - September 2019.jpg — Muntaka Chasant / CC BY-SA 4.0 via Wikimedia Commons</a:t>
             </a:r>
           </a:p>
         </p:txBody>
@@ -5517,7 +5988,7 @@
         </p:blipFill>
         <p:spPr>
           <a:xfrm>
-            <a:off x="3124048" y="1554480"/>
+            <a:off x="3108960" y="1554480"/>
             <a:ext cx="5943600" cy="3657600"/>
           </a:xfrm>
           <a:prstGeom prst="rect">
@@ -5541,7 +6012,7 @@
           </a:prstGeom>
           <a:solidFill>
             <a:srgbClr val="1C1C1E">
-              <a:alpha val="86000"/>
+              <a:alpha val="88000"/>
             </a:srgbClr>
           </a:solidFill>
           <a:ln>
@@ -5579,8 +6050,8 @@
         </p:nvSpPr>
         <p:spPr>
           <a:xfrm>
-            <a:off x="548640" y="365760"/>
-            <a:ext cx="10972800" cy="822960"/>
+            <a:off x="548640" y="274320"/>
+            <a:ext cx="10972800" cy="914400"/>
           </a:xfrm>
           <a:prstGeom prst="rect">
             <a:avLst/>
@@ -5588,19 +6059,35 @@
           <a:noFill/>
         </p:spPr>
         <p:txBody>
-          <a:bodyPr wrap="square" anchor="t" lIns="0" rIns="0" tIns="0" bIns="0">
+          <a:bodyPr wrap="square" anchor="t" lIns="45720" rIns="0" tIns="0" bIns="0">
             <a:spAutoFit/>
           </a:bodyPr>
           <a:lstStyle/>
           <a:p>
             <a:r>
-              <a:rPr sz="2600" b="1" i="0" spc="120">
+              <a:rPr sz="2600" b="1" i="0" spc="100">
                 <a:solidFill>
                   <a:srgbClr val="FFFFFF"/>
                 </a:solidFill>
                 <a:latin typeface="Montserrat ExtraBold"/>
               </a:rPr>
               <a:t>ONE REPAIR.  ONE LESS DEVICE.  ONE LESS TON.</a:t>
+            </a:r>
+          </a:p>
+          <a:p>
+            <a:pPr>
+              <a:spcBef>
+                <a:spcPts val="400"/>
+              </a:spcBef>
+            </a:pPr>
+            <a:r>
+              <a:rPr sz="1300" b="0" i="0">
+                <a:solidFill>
+                  <a:srgbClr val="3DBFB8"/>
+                </a:solidFill>
+                <a:latin typeface="IBM Plex Mono"/>
+              </a:rPr>
+              <a:t>the local-global feedback loop</a:t>
             </a:r>
           </a:p>
         </p:txBody>
@@ -5613,8 +6100,8 @@
         </p:nvCxnSpPr>
         <p:spPr>
           <a:xfrm>
-            <a:off x="6824626" y="2134007"/>
-            <a:ext cx="748153" cy="543564"/>
+            <a:off x="6839421" y="2373356"/>
+            <a:ext cx="631598" cy="458882"/>
           </a:xfrm>
           <a:prstGeom prst="line">
             <a:avLst/>
@@ -5650,8 +6137,8 @@
         </p:nvCxnSpPr>
         <p:spPr>
           <a:xfrm flipH="1">
-            <a:off x="7644692" y="3778403"/>
-            <a:ext cx="478572" cy="1472893"/>
+            <a:off x="7596596" y="3961212"/>
+            <a:ext cx="434052" cy="1335875"/>
           </a:xfrm>
           <a:prstGeom prst="line">
             <a:avLst/>
@@ -5686,9 +6173,9 @@
           <p:nvPr/>
         </p:nvCxnSpPr>
         <p:spPr>
-          <a:xfrm flipH="1">
-            <a:off x="6045233" y="5818321"/>
-            <a:ext cx="89341" cy="0"/>
+          <a:xfrm>
+            <a:off x="6062539" y="5881504"/>
+            <a:ext cx="54729" cy="0"/>
           </a:xfrm>
           <a:prstGeom prst="line">
             <a:avLst/>
@@ -5724,8 +6211,8 @@
         </p:nvCxnSpPr>
         <p:spPr>
           <a:xfrm flipH="1" flipV="1">
-            <a:off x="4056543" y="3778403"/>
-            <a:ext cx="478572" cy="1472893"/>
+            <a:off x="4149159" y="3961212"/>
+            <a:ext cx="434052" cy="1335875"/>
           </a:xfrm>
           <a:prstGeom prst="line">
             <a:avLst/>
@@ -5761,8 +6248,8 @@
         </p:nvCxnSpPr>
         <p:spPr>
           <a:xfrm flipV="1">
-            <a:off x="4607028" y="2134007"/>
-            <a:ext cx="748153" cy="543564"/>
+            <a:off x="4708788" y="2373356"/>
+            <a:ext cx="631598" cy="458882"/>
           </a:xfrm>
           <a:prstGeom prst="line">
             <a:avLst/>
@@ -5798,7 +6285,7 @@
         </p:nvSpPr>
         <p:spPr>
           <a:xfrm>
-            <a:off x="4855464" y="1120140"/>
+            <a:off x="4855464" y="1348740"/>
             <a:ext cx="2468880" cy="960120"/>
           </a:xfrm>
           <a:prstGeom prst="roundRect">
@@ -5865,7 +6352,7 @@
         </p:nvSpPr>
         <p:spPr>
           <a:xfrm>
-            <a:off x="7073061" y="2731318"/>
+            <a:off x="6986096" y="2896735"/>
             <a:ext cx="2468880" cy="960120"/>
           </a:xfrm>
           <a:prstGeom prst="roundRect">
@@ -5932,7 +6419,7 @@
         </p:nvSpPr>
         <p:spPr>
           <a:xfrm>
-            <a:off x="6226014" y="5338261"/>
+            <a:off x="6172267" y="5401444"/>
             <a:ext cx="2468880" cy="960120"/>
           </a:xfrm>
           <a:prstGeom prst="roundRect">
@@ -5999,7 +6486,7 @@
         </p:nvSpPr>
         <p:spPr>
           <a:xfrm>
-            <a:off x="3484913" y="5338261"/>
+            <a:off x="3538660" y="5401444"/>
             <a:ext cx="2468880" cy="960120"/>
           </a:xfrm>
           <a:prstGeom prst="roundRect">
@@ -6066,7 +6553,7 @@
         </p:nvSpPr>
         <p:spPr>
           <a:xfrm>
-            <a:off x="2637866" y="2731318"/>
+            <a:off x="2724831" y="2896735"/>
             <a:ext cx="2468880" cy="960120"/>
           </a:xfrm>
           <a:prstGeom prst="roundRect">
@@ -6133,8 +6620,8 @@
         </p:nvSpPr>
         <p:spPr>
           <a:xfrm>
-            <a:off x="548640" y="6355080"/>
-            <a:ext cx="6400800" cy="365760"/>
+            <a:off x="548640" y="6400800"/>
+            <a:ext cx="7315200" cy="320040"/>
           </a:xfrm>
           <a:prstGeom prst="rect">
             <a:avLst/>
@@ -6142,19 +6629,19 @@
           <a:noFill/>
         </p:spPr>
         <p:txBody>
-          <a:bodyPr wrap="square" anchor="t" lIns="0" rIns="0" tIns="0" bIns="0">
+          <a:bodyPr wrap="square" anchor="t" lIns="45720" rIns="0" tIns="0" bIns="0">
             <a:spAutoFit/>
           </a:bodyPr>
           <a:lstStyle/>
           <a:p>
             <a:r>
-              <a:rPr sz="1200" b="0" i="0">
-                <a:solidFill>
-                  <a:srgbClr val="F0EDE6"/>
+              <a:rPr sz="1100" b="0" i="0">
+                <a:solidFill>
+                  <a:srgbClr val="8A8780"/>
                 </a:solidFill>
                 <a:latin typeface="IBM Plex Mono"/>
               </a:rPr>
-              <a:t>individual action → systemic change</a:t>
+              <a:t>individual action  →  systemic pressure  →  structural change</a:t>
             </a:r>
           </a:p>
         </p:txBody>
@@ -6167,8 +6654,8 @@
         </p:nvSpPr>
         <p:spPr>
           <a:xfrm>
-            <a:off x="11277295" y="6400800"/>
-            <a:ext cx="731520" cy="320040"/>
+            <a:off x="11368735" y="6446520"/>
+            <a:ext cx="640080" cy="274320"/>
           </a:xfrm>
           <a:prstGeom prst="rect">
             <a:avLst/>
@@ -6176,14 +6663,14 @@
           <a:noFill/>
         </p:spPr>
         <p:txBody>
-          <a:bodyPr wrap="square" anchor="t" lIns="0" rIns="0" tIns="0" bIns="0">
+          <a:bodyPr wrap="square" anchor="t" lIns="45720" rIns="0" tIns="0" bIns="0">
             <a:spAutoFit/>
           </a:bodyPr>
           <a:lstStyle/>
           <a:p>
             <a:pPr algn="r"/>
             <a:r>
-              <a:rPr sz="1100" b="0" i="0">
+              <a:rPr sz="1000" b="0" i="0">
                 <a:solidFill>
                   <a:srgbClr val="F5A321"/>
                 </a:solidFill>
@@ -6260,7 +6747,7 @@
           </a:prstGeom>
           <a:solidFill>
             <a:srgbClr val="3DBFB8">
-              <a:alpha val="18000"/>
+              <a:alpha val="15000"/>
             </a:srgbClr>
           </a:solidFill>
           <a:ln>
@@ -6298,15 +6785,15 @@
         </p:nvSpPr>
         <p:spPr>
           <a:xfrm>
-            <a:off x="0" y="4206240"/>
-            <a:ext cx="12191695" cy="2651760"/>
+            <a:off x="0" y="3474720"/>
+            <a:ext cx="12191695" cy="3383280"/>
           </a:xfrm>
           <a:prstGeom prst="rect">
             <a:avLst/>
           </a:prstGeom>
           <a:solidFill>
-            <a:srgbClr val="101414">
-              <a:alpha val="62000"/>
+            <a:srgbClr val="0E1212">
+              <a:alpha val="70000"/>
             </a:srgbClr>
           </a:solidFill>
           <a:ln>
@@ -6344,8 +6831,8 @@
         </p:nvSpPr>
         <p:spPr>
           <a:xfrm>
-            <a:off x="548640" y="4389120"/>
-            <a:ext cx="10972800" cy="2011680"/>
+            <a:off x="640080" y="3657600"/>
+            <a:ext cx="10972800" cy="2926080"/>
           </a:xfrm>
           <a:prstGeom prst="rect">
             <a:avLst/>
@@ -6353,13 +6840,13 @@
           <a:noFill/>
         </p:spPr>
         <p:txBody>
-          <a:bodyPr wrap="square" anchor="t" lIns="0" rIns="0" tIns="0" bIns="0">
+          <a:bodyPr wrap="square" anchor="t" lIns="45720" rIns="0" tIns="0" bIns="0">
             <a:spAutoFit/>
           </a:bodyPr>
           <a:lstStyle/>
           <a:p>
             <a:r>
-              <a:rPr sz="4400" b="1" i="0" spc="160">
+              <a:rPr sz="4600" b="1" i="0" spc="160">
                 <a:solidFill>
                   <a:srgbClr val="FFFFFF"/>
                 </a:solidFill>
@@ -6371,29 +6858,63 @@
           <a:p>
             <a:pPr>
               <a:spcBef>
-                <a:spcPts val="800"/>
+                <a:spcPts val="1000"/>
               </a:spcBef>
             </a:pPr>
             <a:r>
-              <a:rPr sz="1800" b="0" i="0">
+              <a:rPr sz="1900" b="0" i="0">
                 <a:solidFill>
                   <a:srgbClr val="3DBFB8"/>
                 </a:solidFill>
                 <a:latin typeface="IBM Plex Mono"/>
               </a:rPr>
-              <a:t>Repair. Reuse. Demand the right to.</a:t>
+              <a:t>Repair it. Reuse it. Demand the right to.</a:t>
             </a:r>
           </a:p>
           <a:p>
             <a:pPr>
               <a:spcBef>
-                <a:spcPts val="600"/>
+                <a:spcPts val="1400"/>
               </a:spcBef>
             </a:pPr>
             <a:r>
+              <a:rPr sz="1400" b="0" i="1">
+                <a:solidFill>
+                  <a:srgbClr val="F5A321"/>
+                </a:solidFill>
+                <a:latin typeface="IBM Plex Mono"/>
+              </a:rPr>
+              <a:t>"</a:t>
+            </a:r>
+            <a:r>
+              <a:rPr sz="1400" b="0" i="1">
+                <a:solidFill>
+                  <a:srgbClr val="F0EDE6"/>
+                </a:solidFill>
+                <a:latin typeface="IBM Plex Mono"/>
+              </a:rPr>
+              <a:t>The most sustainable device is the one you already own.</a:t>
+            </a:r>
+            <a:r>
+              <a:rPr sz="1400" b="0" i="1">
+                <a:solidFill>
+                  <a:srgbClr val="F5A321"/>
+                </a:solidFill>
+                <a:latin typeface="IBM Plex Mono"/>
+              </a:rPr>
+              <a:t>"</a:t>
+            </a:r>
+          </a:p>
+          <a:p>
+            <a:pPr>
+              <a:spcBef>
+                <a:spcPts val="1600"/>
+              </a:spcBef>
+            </a:pPr>
+            <a:r>
               <a:rPr sz="1500" b="0" i="0">
                 <a:solidFill>
-                  <a:srgbClr val="F0EDE6"/>
+                  <a:srgbClr val="F5A321"/>
                 </a:solidFill>
                 <a:latin typeface="IBM Plex Mono"/>
               </a:rPr>
@@ -6410,8 +6931,8 @@
         </p:nvSpPr>
         <p:spPr>
           <a:xfrm>
-            <a:off x="11277295" y="6400800"/>
-            <a:ext cx="731520" cy="320040"/>
+            <a:off x="640080" y="6035040"/>
+            <a:ext cx="10972800" cy="640080"/>
           </a:xfrm>
           <a:prstGeom prst="rect">
             <a:avLst/>
@@ -6419,20 +6940,19 @@
           <a:noFill/>
         </p:spPr>
         <p:txBody>
-          <a:bodyPr wrap="square" anchor="t" lIns="0" rIns="0" tIns="0" bIns="0">
+          <a:bodyPr wrap="square" anchor="t" lIns="45720" rIns="0" tIns="0" bIns="0">
             <a:spAutoFit/>
           </a:bodyPr>
           <a:lstStyle/>
           <a:p>
-            <a:pPr algn="r"/>
             <a:r>
               <a:rPr sz="1100" b="0" i="0">
                 <a:solidFill>
-                  <a:srgbClr val="F5A321"/>
+                  <a:srgbClr val="8A8780"/>
                 </a:solidFill>
                 <a:latin typeface="IBM Plex Mono"/>
               </a:rPr>
-              <a:t>08</a:t>
+              <a:t>support repair legislation  |  find your local repair cafe  |  choose repairable products</a:t>
             </a:r>
           </a:p>
         </p:txBody>
@@ -6445,8 +6965,8 @@
         </p:nvSpPr>
         <p:spPr>
           <a:xfrm>
-            <a:off x="274320" y="6492240"/>
-            <a:ext cx="9144000" cy="274320"/>
+            <a:off x="11368735" y="6446520"/>
+            <a:ext cx="640080" cy="274320"/>
           </a:xfrm>
           <a:prstGeom prst="rect">
             <a:avLst/>
@@ -6454,19 +6974,20 @@
           <a:noFill/>
         </p:spPr>
         <p:txBody>
-          <a:bodyPr wrap="square" anchor="t" lIns="0" rIns="0" tIns="0" bIns="0">
+          <a:bodyPr wrap="square" anchor="t" lIns="45720" rIns="0" tIns="0" bIns="0">
             <a:spAutoFit/>
           </a:bodyPr>
           <a:lstStyle/>
           <a:p>
-            <a:r>
-              <a:rPr sz="700" b="0" i="0">
-                <a:solidFill>
-                  <a:srgbClr val="9A9790"/>
+            <a:pPr algn="r"/>
+            <a:r>
+              <a:rPr sz="1000" b="0" i="0">
+                <a:solidFill>
+                  <a:srgbClr val="F5A321"/>
                 </a:solidFill>
                 <a:latin typeface="IBM Plex Mono"/>
               </a:rPr>
-              <a:t>Image: EFTA00001374 - Cluttered workspace filled with electronic equipment cables and boxes on a workbench.jpg — Federal Bureau of Investigation / Public domain via Wikimedia Commons</a:t>
+              <a:t>08</a:t>
             </a:r>
           </a:p>
         </p:txBody>

</xml_diff>